<commit_message>
Document fresh Colab verification
</commit_message>
<xml_diff>
--- a/milestone3/deliverables/FIT5230_M3_Context_Matters_Presentation.pptx
+++ b/milestone3/deliverables/FIT5230_M3_Context_Matters_Presentation.pptx
@@ -2,23 +2,23 @@
 <file path=ppt/presentation.xml><?xml version="1.0" encoding="utf-8"?>
 <p:presentation xmlns:p="http://schemas.openxmlformats.org/presentationml/2006/main">
   <p:sldMasterIdLst>
-    <p:sldMasterId xmlns:r="http://schemas.openxmlformats.org/officeDocument/2006/relationships" id="2147483648" r:id="Rb75b6fde60354b01"/>
+    <p:sldMasterId xmlns:r="http://schemas.openxmlformats.org/officeDocument/2006/relationships" id="2147483648" r:id="Rbe1d5980934d4fe4"/>
   </p:sldMasterIdLst>
   <p:notesMasterIdLst>
-    <p:notesMasterId xmlns:r="http://schemas.openxmlformats.org/officeDocument/2006/relationships" r:id="R3a1fcc616afc4473"/>
+    <p:notesMasterId xmlns:r="http://schemas.openxmlformats.org/officeDocument/2006/relationships" r:id="R5075fc2d605e4f54"/>
   </p:notesMasterIdLst>
   <p:sldIdLst>
-    <p:sldId xmlns:r="http://schemas.openxmlformats.org/officeDocument/2006/relationships" id="256" r:id="R92667b0f99c94535"/>
-    <p:sldId xmlns:r="http://schemas.openxmlformats.org/officeDocument/2006/relationships" id="257" r:id="Rd4084cd302d74f84"/>
-    <p:sldId xmlns:r="http://schemas.openxmlformats.org/officeDocument/2006/relationships" id="258" r:id="R6b47ff7741da4bd7"/>
-    <p:sldId xmlns:r="http://schemas.openxmlformats.org/officeDocument/2006/relationships" id="259" r:id="R8478673b151f4cdf"/>
-    <p:sldId xmlns:r="http://schemas.openxmlformats.org/officeDocument/2006/relationships" id="260" r:id="Rdc8b6924a1b04136"/>
-    <p:sldId xmlns:r="http://schemas.openxmlformats.org/officeDocument/2006/relationships" id="261" r:id="Rc771761a67c84f9d"/>
-    <p:sldId xmlns:r="http://schemas.openxmlformats.org/officeDocument/2006/relationships" id="262" r:id="Rc1c6192b75664680"/>
-    <p:sldId xmlns:r="http://schemas.openxmlformats.org/officeDocument/2006/relationships" id="263" r:id="R91ff990d3e48443e"/>
-    <p:sldId xmlns:r="http://schemas.openxmlformats.org/officeDocument/2006/relationships" id="264" r:id="Ree92cf089bef4fd7"/>
-    <p:sldId xmlns:r="http://schemas.openxmlformats.org/officeDocument/2006/relationships" id="265" r:id="R50fc8b72492e4b70"/>
-    <p:sldId xmlns:r="http://schemas.openxmlformats.org/officeDocument/2006/relationships" id="266" r:id="R20d211139c1847ca"/>
+    <p:sldId xmlns:r="http://schemas.openxmlformats.org/officeDocument/2006/relationships" id="256" r:id="R82d3eca1ee40489a"/>
+    <p:sldId xmlns:r="http://schemas.openxmlformats.org/officeDocument/2006/relationships" id="257" r:id="R527944fb5cf74d79"/>
+    <p:sldId xmlns:r="http://schemas.openxmlformats.org/officeDocument/2006/relationships" id="258" r:id="R57561eaa0fca4d81"/>
+    <p:sldId xmlns:r="http://schemas.openxmlformats.org/officeDocument/2006/relationships" id="259" r:id="Ra12494ab623a4053"/>
+    <p:sldId xmlns:r="http://schemas.openxmlformats.org/officeDocument/2006/relationships" id="260" r:id="R5293c4c24f2f47bc"/>
+    <p:sldId xmlns:r="http://schemas.openxmlformats.org/officeDocument/2006/relationships" id="261" r:id="R2b2380a5a14d466e"/>
+    <p:sldId xmlns:r="http://schemas.openxmlformats.org/officeDocument/2006/relationships" id="262" r:id="R6d8e2b45e22a4ade"/>
+    <p:sldId xmlns:r="http://schemas.openxmlformats.org/officeDocument/2006/relationships" id="263" r:id="Rd914f504851b4404"/>
+    <p:sldId xmlns:r="http://schemas.openxmlformats.org/officeDocument/2006/relationships" id="264" r:id="Rdb8ec15ec3024a79"/>
+    <p:sldId xmlns:r="http://schemas.openxmlformats.org/officeDocument/2006/relationships" id="265" r:id="R738dbb00e8b04aa8"/>
+    <p:sldId xmlns:r="http://schemas.openxmlformats.org/officeDocument/2006/relationships" id="266" r:id="R69c0d8cc4c5d4421"/>
   </p:sldIdLst>
   <p:sldSz cx="12192000" cy="6858000"/>
   <p:notesSz cx="6858000" cy="9144000"/>
@@ -942,7 +942,7 @@
           <a:lstStyle xmlns:a="http://schemas.openxmlformats.org/drawingml/2006/main"/>
           <a:p xmlns:a="http://schemas.openxmlformats.org/drawingml/2006/main">
             <a:r>
-              <a:t>Yan, 105 seconds. On six held-out clips, the context-free model reached macro-F1 0.486 and AUROC 0.667. The weak context model had the same macro-F1 and AUROC 0.556. Five thousand paired stratified bootstrap resamples give wide intervals because the test set contains only three real and three fake clips. The correct conclusion is that this weak context implementation does not improve the pilot. Source: artifacts/m3_results/test_metrics_with_bootstrap.csv.</a:t>
+              <a:t>Yan, 105 seconds. On six held-out clips, the saved reference run gave macro-F1 0.486 for both models and AUROC 0.667 versus 0.556. A fresh Colab CPU rerun gave the same macro-F1 and AUROC 0.556 versus 0.444. The AUROC change remained minus 0.111. Five thousand paired stratified bootstrap resamples give wide intervals because the test set contains only three real and three fake clips. The correct conclusion is that this weak context implementation does not improve the pilot. Sources: artifacts/m3_results/test_metrics_with_bootstrap.csv and reports/M3_COLAB_VERIFICATION.md.</a:t>
             </a:r>
           </a:p>
         </p:txBody>
@@ -1199,7 +1199,7 @@
           <p:cNvPr id="3" name="Title">
             <a:extLst xmlns:a="http://schemas.openxmlformats.org/drawingml/2006/main">
               <a:ext uri="{FF2B5EF4-FFF2-40B4-BE49-F238E27FC236}">
-                <a16:creationId xmlns:a16="http://schemas.microsoft.com/office/drawing/2014/main" id="{1789AF54-C53B-4E4F-9077-4B4DF87A1E1F}"/>
+                <a16:creationId xmlns:a16="http://schemas.microsoft.com/office/drawing/2014/main" id="{8AAB0776-C2F8-4370-9F7F-BACF80DBACD4}"/>
               </a:ext>
             </a:extLst>
           </p:cNvPr>
@@ -1356,7 +1356,7 @@
           <p:cNvPr id="2" name="Subtitle">
             <a:extLst xmlns:a="http://schemas.openxmlformats.org/drawingml/2006/main">
               <a:ext uri="{FF2B5EF4-FFF2-40B4-BE49-F238E27FC236}">
-                <a16:creationId xmlns:a16="http://schemas.microsoft.com/office/drawing/2014/main" id="{2EB53D66-D407-4FA4-95BE-D10D7503D662}"/>
+                <a16:creationId xmlns:a16="http://schemas.microsoft.com/office/drawing/2014/main" id="{34884644-F796-44B8-9AEE-8AF5189E500B}"/>
               </a:ext>
             </a:extLst>
           </p:cNvPr>
@@ -1530,7 +1530,7 @@
           <p:cNvPr id="2" name="Section title">
             <a:extLst xmlns:a="http://schemas.openxmlformats.org/drawingml/2006/main">
               <a:ext uri="{FF2B5EF4-FFF2-40B4-BE49-F238E27FC236}">
-                <a16:creationId xmlns:a16="http://schemas.microsoft.com/office/drawing/2014/main" id="{10A3860F-2A82-4C21-A343-9C8DE4EEAF3D}"/>
+                <a16:creationId xmlns:a16="http://schemas.microsoft.com/office/drawing/2014/main" id="{0AC132E7-4B01-452E-942B-86616E85FA48}"/>
               </a:ext>
             </a:extLst>
           </p:cNvPr>
@@ -1704,7 +1704,7 @@
           <p:cNvPr id="3" name="Title">
             <a:extLst xmlns:a="http://schemas.openxmlformats.org/drawingml/2006/main">
               <a:ext uri="{FF2B5EF4-FFF2-40B4-BE49-F238E27FC236}">
-                <a16:creationId xmlns:a16="http://schemas.microsoft.com/office/drawing/2014/main" id="{88563A25-69F4-4D95-8ABE-A9ED136DCD75}"/>
+                <a16:creationId xmlns:a16="http://schemas.microsoft.com/office/drawing/2014/main" id="{2B2F8733-8A48-4E56-A0B9-12007576D1C0}"/>
               </a:ext>
             </a:extLst>
           </p:cNvPr>
@@ -1861,7 +1861,7 @@
           <p:cNvPr id="2" name="Body">
             <a:extLst xmlns:a="http://schemas.openxmlformats.org/drawingml/2006/main">
               <a:ext uri="{FF2B5EF4-FFF2-40B4-BE49-F238E27FC236}">
-                <a16:creationId xmlns:a16="http://schemas.microsoft.com/office/drawing/2014/main" id="{96A945C8-A972-4930-837E-83F915DBD308}"/>
+                <a16:creationId xmlns:a16="http://schemas.microsoft.com/office/drawing/2014/main" id="{6970B4A5-A702-4B3F-BB47-12B84482C0C9}"/>
               </a:ext>
             </a:extLst>
           </p:cNvPr>
@@ -2035,7 +2035,7 @@
           <p:cNvPr id="4" name="Title">
             <a:extLst xmlns:a="http://schemas.openxmlformats.org/drawingml/2006/main">
               <a:ext uri="{FF2B5EF4-FFF2-40B4-BE49-F238E27FC236}">
-                <a16:creationId xmlns:a16="http://schemas.microsoft.com/office/drawing/2014/main" id="{3FDB12AC-6176-41EE-8FC9-F41B73AE2084}"/>
+                <a16:creationId xmlns:a16="http://schemas.microsoft.com/office/drawing/2014/main" id="{A452F54A-4269-4A80-8381-B59BDDAEAA6C}"/>
               </a:ext>
             </a:extLst>
           </p:cNvPr>
@@ -2192,7 +2192,7 @@
           <p:cNvPr id="2" name="Left column">
             <a:extLst xmlns:a="http://schemas.openxmlformats.org/drawingml/2006/main">
               <a:ext uri="{FF2B5EF4-FFF2-40B4-BE49-F238E27FC236}">
-                <a16:creationId xmlns:a16="http://schemas.microsoft.com/office/drawing/2014/main" id="{38D3BB33-C2C9-49F7-949A-B042A63D7E2E}"/>
+                <a16:creationId xmlns:a16="http://schemas.microsoft.com/office/drawing/2014/main" id="{DBB68AC5-442C-4ECB-9960-EA2D85241C80}"/>
               </a:ext>
             </a:extLst>
           </p:cNvPr>
@@ -2349,7 +2349,7 @@
           <p:cNvPr id="3" name="Right column">
             <a:extLst xmlns:a="http://schemas.openxmlformats.org/drawingml/2006/main">
               <a:ext uri="{FF2B5EF4-FFF2-40B4-BE49-F238E27FC236}">
-                <a16:creationId xmlns:a16="http://schemas.microsoft.com/office/drawing/2014/main" id="{554D0B23-61C3-4570-AAA7-8D3227807F19}"/>
+                <a16:creationId xmlns:a16="http://schemas.microsoft.com/office/drawing/2014/main" id="{192B05C1-9F14-4D76-9355-F0CF3CAD122D}"/>
               </a:ext>
             </a:extLst>
           </p:cNvPr>
@@ -2523,7 +2523,7 @@
           <p:cNvPr id="3" name="Title">
             <a:extLst xmlns:a="http://schemas.openxmlformats.org/drawingml/2006/main">
               <a:ext uri="{FF2B5EF4-FFF2-40B4-BE49-F238E27FC236}">
-                <a16:creationId xmlns:a16="http://schemas.microsoft.com/office/drawing/2014/main" id="{9D2ABB3B-52A0-48EF-8C67-911731B2FF8A}"/>
+                <a16:creationId xmlns:a16="http://schemas.microsoft.com/office/drawing/2014/main" id="{B437E662-3AEF-4A99-86D5-89E4CAC75E46}"/>
               </a:ext>
             </a:extLst>
           </p:cNvPr>
@@ -2680,7 +2680,7 @@
           <p:cNvPr id="2" name="Left column">
             <a:extLst xmlns:a="http://schemas.openxmlformats.org/drawingml/2006/main">
               <a:ext uri="{FF2B5EF4-FFF2-40B4-BE49-F238E27FC236}">
-                <a16:creationId xmlns:a16="http://schemas.microsoft.com/office/drawing/2014/main" id="{57E78E39-B62C-4ED3-9B58-8135DE0D84C1}"/>
+                <a16:creationId xmlns:a16="http://schemas.microsoft.com/office/drawing/2014/main" id="{743409EE-D28A-4392-AEBF-BB94F0F40EC1}"/>
               </a:ext>
             </a:extLst>
           </p:cNvPr>
@@ -2875,12 +2875,12 @@
   </p:cSld>
   <p:clrMap bg1="lt1" tx1="dk1" bg2="lt2" tx2="dk2" accent1="accent1" accent2="accent2" accent3="accent3" accent4="accent4" accent5="accent5" accent6="accent6" hlink="hlink" folHlink="folHlink"/>
   <p:sldLayoutIdLst>
-    <p:sldLayoutId xmlns:r="http://schemas.openxmlformats.org/officeDocument/2006/relationships" id="2147483649" r:id="Re473f5cce03b4d0d"/>
-    <p:sldLayoutId xmlns:r="http://schemas.openxmlformats.org/officeDocument/2006/relationships" id="2147483650" r:id="Rf3cf4c2338bc4b74"/>
-    <p:sldLayoutId xmlns:r="http://schemas.openxmlformats.org/officeDocument/2006/relationships" id="2147483651" r:id="R7528c8a3f73d40c3"/>
-    <p:sldLayoutId xmlns:r="http://schemas.openxmlformats.org/officeDocument/2006/relationships" id="2147483652" r:id="R10d33c086b364eac"/>
-    <p:sldLayoutId xmlns:r="http://schemas.openxmlformats.org/officeDocument/2006/relationships" id="2147483653" r:id="Rb776db5b78ef4c64"/>
-    <p:sldLayoutId xmlns:r="http://schemas.openxmlformats.org/officeDocument/2006/relationships" id="2147483654" r:id="Re7ac90cd55134b99"/>
+    <p:sldLayoutId xmlns:r="http://schemas.openxmlformats.org/officeDocument/2006/relationships" id="2147483649" r:id="Rc429333f0e0f4017"/>
+    <p:sldLayoutId xmlns:r="http://schemas.openxmlformats.org/officeDocument/2006/relationships" id="2147483650" r:id="R69538f462c5c4d23"/>
+    <p:sldLayoutId xmlns:r="http://schemas.openxmlformats.org/officeDocument/2006/relationships" id="2147483651" r:id="R889f0777c2ad4a65"/>
+    <p:sldLayoutId xmlns:r="http://schemas.openxmlformats.org/officeDocument/2006/relationships" id="2147483652" r:id="Ra50b8adbd2344acb"/>
+    <p:sldLayoutId xmlns:r="http://schemas.openxmlformats.org/officeDocument/2006/relationships" id="2147483653" r:id="R19e2c42ed1444cc0"/>
+    <p:sldLayoutId xmlns:r="http://schemas.openxmlformats.org/officeDocument/2006/relationships" id="2147483654" r:id="R472b47329e384ea3"/>
   </p:sldLayoutIdLst>
   <p:txStyles>
     <p:titleStyle>
@@ -5584,7 +5584,7 @@
           <p:cNvPr id="10" name="">
             <a:extLst xmlns:a="http://schemas.openxmlformats.org/drawingml/2006/main">
               <a:ext uri="{FF2B5EF4-FFF2-40B4-BE49-F238E27FC236}">
-                <a16:creationId xmlns:a16="http://schemas.microsoft.com/office/drawing/2014/main" id="{28E01C19-9C99-4B65-B6D5-81E45B0A5648}"/>
+                <a16:creationId xmlns:a16="http://schemas.microsoft.com/office/drawing/2014/main" id="{A6253C7C-4705-4576-9D67-9FBE819B6D8C}"/>
               </a:ext>
             </a:extLst>
           </p:cNvPr>
@@ -5614,7 +5614,7 @@
           <p:cNvPr id="2" name="">
             <a:extLst xmlns:a="http://schemas.openxmlformats.org/drawingml/2006/main">
               <a:ext uri="{FF2B5EF4-FFF2-40B4-BE49-F238E27FC236}">
-                <a16:creationId xmlns:a16="http://schemas.microsoft.com/office/drawing/2014/main" id="{94B9A7DD-49CE-4050-AFF9-8C5167D61F65}"/>
+                <a16:creationId xmlns:a16="http://schemas.microsoft.com/office/drawing/2014/main" id="{C3FA3552-182B-4057-8F3A-4AE71376BEA9}"/>
               </a:ext>
             </a:extLst>
           </p:cNvPr>
@@ -5682,7 +5682,7 @@
           <p:cNvPr id="3" name="">
             <a:extLst xmlns:a="http://schemas.openxmlformats.org/drawingml/2006/main">
               <a:ext uri="{FF2B5EF4-FFF2-40B4-BE49-F238E27FC236}">
-                <a16:creationId xmlns:a16="http://schemas.microsoft.com/office/drawing/2014/main" id="{240EB740-4DDA-44BE-A19C-4C369A0F5D43}"/>
+                <a16:creationId xmlns:a16="http://schemas.microsoft.com/office/drawing/2014/main" id="{972F6B2C-FAC2-48EF-AEAE-AE9EDD775285}"/>
               </a:ext>
             </a:extLst>
           </p:cNvPr>
@@ -5750,7 +5750,7 @@
           <p:cNvPr id="4" name="">
             <a:extLst xmlns:a="http://schemas.openxmlformats.org/drawingml/2006/main">
               <a:ext uri="{FF2B5EF4-FFF2-40B4-BE49-F238E27FC236}">
-                <a16:creationId xmlns:a16="http://schemas.microsoft.com/office/drawing/2014/main" id="{3F762E45-0500-45E0-BC63-910D837AA1D0}"/>
+                <a16:creationId xmlns:a16="http://schemas.microsoft.com/office/drawing/2014/main" id="{6BE6DF9A-ED11-4363-8504-C63A0D3B3EE7}"/>
               </a:ext>
             </a:extLst>
           </p:cNvPr>
@@ -5780,7 +5780,7 @@
           <p:cNvPr id="5" name="">
             <a:extLst xmlns:a="http://schemas.openxmlformats.org/drawingml/2006/main">
               <a:ext uri="{FF2B5EF4-FFF2-40B4-BE49-F238E27FC236}">
-                <a16:creationId xmlns:a16="http://schemas.microsoft.com/office/drawing/2014/main" id="{07CBFDF1-746D-4308-A0DE-D6A8DA92F41B}"/>
+                <a16:creationId xmlns:a16="http://schemas.microsoft.com/office/drawing/2014/main" id="{A578068F-1298-4596-AD0E-785C676B806C}"/>
               </a:ext>
             </a:extLst>
           </p:cNvPr>
@@ -5848,7 +5848,7 @@
           <p:cNvPr id="6" name="">
             <a:extLst xmlns:a="http://schemas.openxmlformats.org/drawingml/2006/main">
               <a:ext uri="{FF2B5EF4-FFF2-40B4-BE49-F238E27FC236}">
-                <a16:creationId xmlns:a16="http://schemas.microsoft.com/office/drawing/2014/main" id="{1224F06A-40D4-429E-92F4-AC0920ACBF38}"/>
+                <a16:creationId xmlns:a16="http://schemas.microsoft.com/office/drawing/2014/main" id="{53F5EA00-ADD3-42E6-B0A4-D97CA43D3B0E}"/>
               </a:ext>
             </a:extLst>
           </p:cNvPr>
@@ -5916,7 +5916,7 @@
           <p:cNvPr id="7" name="">
             <a:extLst xmlns:a="http://schemas.openxmlformats.org/drawingml/2006/main">
               <a:ext uri="{FF2B5EF4-FFF2-40B4-BE49-F238E27FC236}">
-                <a16:creationId xmlns:a16="http://schemas.microsoft.com/office/drawing/2014/main" id="{005960FE-73D6-4281-9A3C-2C3F0E70D799}"/>
+                <a16:creationId xmlns:a16="http://schemas.microsoft.com/office/drawing/2014/main" id="{BC783CA1-BEB5-4416-9EE0-F5C73596913C}"/>
               </a:ext>
             </a:extLst>
           </p:cNvPr>
@@ -5984,7 +5984,7 @@
           <p:cNvPr id="8" name="">
             <a:extLst xmlns:a="http://schemas.openxmlformats.org/drawingml/2006/main">
               <a:ext uri="{FF2B5EF4-FFF2-40B4-BE49-F238E27FC236}">
-                <a16:creationId xmlns:a16="http://schemas.microsoft.com/office/drawing/2014/main" id="{5837CFE9-A59B-4D71-8F73-FF303FB958F8}"/>
+                <a16:creationId xmlns:a16="http://schemas.microsoft.com/office/drawing/2014/main" id="{AEC4C6E5-866A-45C1-9D88-3D4805887DF3}"/>
               </a:ext>
             </a:extLst>
           </p:cNvPr>
@@ -6052,7 +6052,7 @@
           <p:cNvPr id="9" name="">
             <a:extLst xmlns:a="http://schemas.openxmlformats.org/drawingml/2006/main">
               <a:ext uri="{FF2B5EF4-FFF2-40B4-BE49-F238E27FC236}">
-                <a16:creationId xmlns:a16="http://schemas.microsoft.com/office/drawing/2014/main" id="{7CEC4958-CD2A-458C-B592-147700BCA9D1}"/>
+                <a16:creationId xmlns:a16="http://schemas.microsoft.com/office/drawing/2014/main" id="{B12B3B66-5CAB-41AC-873C-4B95B5EF68BB}"/>
               </a:ext>
             </a:extLst>
           </p:cNvPr>
@@ -6118,7 +6118,7 @@
     </p:spTree>
     <p:extLst>
       <p:ext uri="{BB962C8B-B14F-4D97-AF65-F5344CB8AC3E}">
-        <p14:creationId xmlns:p14="http://schemas.microsoft.com/office/powerpoint/2010/main" val="1486029883"/>
+        <p14:creationId xmlns:p14="http://schemas.microsoft.com/office/powerpoint/2010/main" val="473402194"/>
       </p:ext>
     </p:extLst>
   </p:cSld>
@@ -6149,7 +6149,7 @@
           <p:cNvPr id="18" name="">
             <a:extLst xmlns:a="http://schemas.openxmlformats.org/drawingml/2006/main">
               <a:ext uri="{FF2B5EF4-FFF2-40B4-BE49-F238E27FC236}">
-                <a16:creationId xmlns:a16="http://schemas.microsoft.com/office/drawing/2014/main" id="{5FC9C6AD-784A-4F98-A5AF-8114C12F15FE}"/>
+                <a16:creationId xmlns:a16="http://schemas.microsoft.com/office/drawing/2014/main" id="{4F34737E-4761-4E7C-B8B3-7C1613143AFE}"/>
               </a:ext>
             </a:extLst>
           </p:cNvPr>
@@ -6217,7 +6217,7 @@
           <p:cNvPr id="2" name="">
             <a:extLst xmlns:a="http://schemas.openxmlformats.org/drawingml/2006/main">
               <a:ext uri="{FF2B5EF4-FFF2-40B4-BE49-F238E27FC236}">
-                <a16:creationId xmlns:a16="http://schemas.microsoft.com/office/drawing/2014/main" id="{F321C6E7-706A-459B-8318-80C891EDA63B}"/>
+                <a16:creationId xmlns:a16="http://schemas.microsoft.com/office/drawing/2014/main" id="{F356B51D-901A-4FE5-922E-F740C5A4CC84}"/>
               </a:ext>
             </a:extLst>
           </p:cNvPr>
@@ -6285,7 +6285,7 @@
           <p:cNvPr id="3" name="">
             <a:extLst xmlns:a="http://schemas.openxmlformats.org/drawingml/2006/main">
               <a:ext uri="{FF2B5EF4-FFF2-40B4-BE49-F238E27FC236}">
-                <a16:creationId xmlns:a16="http://schemas.microsoft.com/office/drawing/2014/main" id="{C08B7A11-1077-463C-A2C2-2DAA7EFCF376}"/>
+                <a16:creationId xmlns:a16="http://schemas.microsoft.com/office/drawing/2014/main" id="{42DA0F0D-73EA-40B3-A9CD-C612CB899577}"/>
               </a:ext>
             </a:extLst>
           </p:cNvPr>
@@ -6315,7 +6315,7 @@
           <p:cNvPr id="4" name="">
             <a:extLst xmlns:a="http://schemas.openxmlformats.org/drawingml/2006/main">
               <a:ext uri="{FF2B5EF4-FFF2-40B4-BE49-F238E27FC236}">
-                <a16:creationId xmlns:a16="http://schemas.microsoft.com/office/drawing/2014/main" id="{9C71A883-A4F5-4C95-87D4-3B9E59DDA209}"/>
+                <a16:creationId xmlns:a16="http://schemas.microsoft.com/office/drawing/2014/main" id="{61950D0B-4E2C-4F2E-9EC4-B325E22E6B7C}"/>
               </a:ext>
             </a:extLst>
           </p:cNvPr>
@@ -6383,7 +6383,7 @@
           <p:cNvPr id="5" name="">
             <a:extLst xmlns:a="http://schemas.openxmlformats.org/drawingml/2006/main">
               <a:ext uri="{FF2B5EF4-FFF2-40B4-BE49-F238E27FC236}">
-                <a16:creationId xmlns:a16="http://schemas.microsoft.com/office/drawing/2014/main" id="{D1839D58-020E-4813-B5C4-30B3B8C99784}"/>
+                <a16:creationId xmlns:a16="http://schemas.microsoft.com/office/drawing/2014/main" id="{BB84BCEE-0CA4-432B-8E61-AF611891AEFE}"/>
               </a:ext>
             </a:extLst>
           </p:cNvPr>
@@ -6451,7 +6451,7 @@
           <p:cNvPr id="6" name="Chart">
             <a:extLst xmlns:a="http://schemas.openxmlformats.org/drawingml/2006/main">
               <a:ext uri="{FF2B5EF4-FFF2-40B4-BE49-F238E27FC236}">
-                <a16:creationId xmlns:a16="http://schemas.microsoft.com/office/drawing/2014/main" id="{6148AFCB-13FB-4850-AB33-F084875A9749}"/>
+                <a16:creationId xmlns:a16="http://schemas.microsoft.com/office/drawing/2014/main" id="{517E9853-7347-4D15-918A-6A64BC0643C3}"/>
               </a:ext>
             </a:extLst>
           </p:cNvPr>
@@ -6464,7 +6464,7 @@
         </p:xfrm>
         <a:graphic xmlns:a="http://schemas.openxmlformats.org/drawingml/2006/main">
           <a:graphicData uri="http://schemas.openxmlformats.org/drawingml/2006/chart">
-            <c:chart xmlns:r="http://schemas.openxmlformats.org/officeDocument/2006/relationships" xmlns:c="http://schemas.openxmlformats.org/drawingml/2006/chart" r:id="R8474ef2a1b7144e1"/>
+            <c:chart xmlns:r="http://schemas.openxmlformats.org/officeDocument/2006/relationships" xmlns:c="http://schemas.openxmlformats.org/drawingml/2006/chart" r:id="R26b23b28484a4688"/>
           </a:graphicData>
         </a:graphic>
       </p:graphicFrame>
@@ -6473,7 +6473,7 @@
           <p:cNvPr id="7" name="">
             <a:extLst xmlns:a="http://schemas.openxmlformats.org/drawingml/2006/main">
               <a:ext uri="{FF2B5EF4-FFF2-40B4-BE49-F238E27FC236}">
-                <a16:creationId xmlns:a16="http://schemas.microsoft.com/office/drawing/2014/main" id="{8A67A616-3A9F-4CBF-8D1C-57F3EE7C6798}"/>
+                <a16:creationId xmlns:a16="http://schemas.microsoft.com/office/drawing/2014/main" id="{E8DAEEBC-20C3-4F61-A3EE-D171AFEABCEF}"/>
               </a:ext>
             </a:extLst>
           </p:cNvPr>
@@ -6541,7 +6541,7 @@
           <p:cNvPr id="8" name="">
             <a:extLst xmlns:a="http://schemas.openxmlformats.org/drawingml/2006/main">
               <a:ext uri="{FF2B5EF4-FFF2-40B4-BE49-F238E27FC236}">
-                <a16:creationId xmlns:a16="http://schemas.microsoft.com/office/drawing/2014/main" id="{3F7E532E-D1A4-4868-BED4-11651EAD854A}"/>
+                <a16:creationId xmlns:a16="http://schemas.microsoft.com/office/drawing/2014/main" id="{5B24AC03-5218-4018-A63B-4A0DF163E3BE}"/>
               </a:ext>
             </a:extLst>
           </p:cNvPr>
@@ -6609,7 +6609,7 @@
           <p:cNvPr id="9" name="">
             <a:extLst xmlns:a="http://schemas.openxmlformats.org/drawingml/2006/main">
               <a:ext uri="{FF2B5EF4-FFF2-40B4-BE49-F238E27FC236}">
-                <a16:creationId xmlns:a16="http://schemas.microsoft.com/office/drawing/2014/main" id="{560327AE-27A3-47F9-86B8-B340E4707124}"/>
+                <a16:creationId xmlns:a16="http://schemas.microsoft.com/office/drawing/2014/main" id="{879DCD84-F93F-46BD-BC1F-E28251F9FC1E}"/>
               </a:ext>
             </a:extLst>
           </p:cNvPr>
@@ -6677,7 +6677,7 @@
           <p:cNvPr id="10" name="">
             <a:extLst xmlns:a="http://schemas.openxmlformats.org/drawingml/2006/main">
               <a:ext uri="{FF2B5EF4-FFF2-40B4-BE49-F238E27FC236}">
-                <a16:creationId xmlns:a16="http://schemas.microsoft.com/office/drawing/2014/main" id="{19D2216C-FCCB-497F-B4B6-9DFA86D1344C}"/>
+                <a16:creationId xmlns:a16="http://schemas.microsoft.com/office/drawing/2014/main" id="{DAC4473B-D6B1-43A6-B99D-885055ED87C8}"/>
               </a:ext>
             </a:extLst>
           </p:cNvPr>
@@ -6745,7 +6745,7 @@
           <p:cNvPr id="11" name="">
             <a:extLst xmlns:a="http://schemas.openxmlformats.org/drawingml/2006/main">
               <a:ext uri="{FF2B5EF4-FFF2-40B4-BE49-F238E27FC236}">
-                <a16:creationId xmlns:a16="http://schemas.microsoft.com/office/drawing/2014/main" id="{5579BAD3-F254-4297-8F4F-BF941B96383D}"/>
+                <a16:creationId xmlns:a16="http://schemas.microsoft.com/office/drawing/2014/main" id="{190F00AD-BACE-4176-9F37-96490E2D895B}"/>
               </a:ext>
             </a:extLst>
           </p:cNvPr>
@@ -6813,7 +6813,7 @@
           <p:cNvPr id="12" name="">
             <a:extLst xmlns:a="http://schemas.openxmlformats.org/drawingml/2006/main">
               <a:ext uri="{FF2B5EF4-FFF2-40B4-BE49-F238E27FC236}">
-                <a16:creationId xmlns:a16="http://schemas.microsoft.com/office/drawing/2014/main" id="{C590C348-CF43-48F8-B73A-1AFA17B65121}"/>
+                <a16:creationId xmlns:a16="http://schemas.microsoft.com/office/drawing/2014/main" id="{27F1CE76-7F2A-4464-BBD6-0BB10A36CF13}"/>
               </a:ext>
             </a:extLst>
           </p:cNvPr>
@@ -6881,7 +6881,7 @@
           <p:cNvPr id="13" name="">
             <a:extLst xmlns:a="http://schemas.openxmlformats.org/drawingml/2006/main">
               <a:ext uri="{FF2B5EF4-FFF2-40B4-BE49-F238E27FC236}">
-                <a16:creationId xmlns:a16="http://schemas.microsoft.com/office/drawing/2014/main" id="{23156218-0DEC-4D25-90C9-6F0B65E5D7EA}"/>
+                <a16:creationId xmlns:a16="http://schemas.microsoft.com/office/drawing/2014/main" id="{00C2F124-7C6E-4724-AD8D-059194FE0558}"/>
               </a:ext>
             </a:extLst>
           </p:cNvPr>
@@ -6949,7 +6949,7 @@
           <p:cNvPr id="14" name="">
             <a:extLst xmlns:a="http://schemas.openxmlformats.org/drawingml/2006/main">
               <a:ext uri="{FF2B5EF4-FFF2-40B4-BE49-F238E27FC236}">
-                <a16:creationId xmlns:a16="http://schemas.microsoft.com/office/drawing/2014/main" id="{139701E6-9BD4-4C62-83E6-0F24EDD6FF39}"/>
+                <a16:creationId xmlns:a16="http://schemas.microsoft.com/office/drawing/2014/main" id="{E043D2D0-2448-4B31-A14D-FEF9F8CE5196}"/>
               </a:ext>
             </a:extLst>
           </p:cNvPr>
@@ -7017,7 +7017,7 @@
           <p:cNvPr id="15" name="">
             <a:extLst xmlns:a="http://schemas.openxmlformats.org/drawingml/2006/main">
               <a:ext uri="{FF2B5EF4-FFF2-40B4-BE49-F238E27FC236}">
-                <a16:creationId xmlns:a16="http://schemas.microsoft.com/office/drawing/2014/main" id="{41E06E84-BE6E-49F5-B684-5832F2EE044D}"/>
+                <a16:creationId xmlns:a16="http://schemas.microsoft.com/office/drawing/2014/main" id="{35808D1D-53FC-40E5-82A5-DC35A8FD65E1}"/>
               </a:ext>
             </a:extLst>
           </p:cNvPr>
@@ -7085,7 +7085,7 @@
           <p:cNvPr id="16" name="">
             <a:extLst xmlns:a="http://schemas.openxmlformats.org/drawingml/2006/main">
               <a:ext uri="{FF2B5EF4-FFF2-40B4-BE49-F238E27FC236}">
-                <a16:creationId xmlns:a16="http://schemas.microsoft.com/office/drawing/2014/main" id="{ABCD0C77-3E0F-4DF9-AE55-19A22F0693BF}"/>
+                <a16:creationId xmlns:a16="http://schemas.microsoft.com/office/drawing/2014/main" id="{CF4CFA7B-7F5F-44C5-AA65-B309B9972BEB}"/>
               </a:ext>
             </a:extLst>
           </p:cNvPr>
@@ -7153,7 +7153,7 @@
           <p:cNvPr id="17" name="">
             <a:extLst xmlns:a="http://schemas.openxmlformats.org/drawingml/2006/main">
               <a:ext uri="{FF2B5EF4-FFF2-40B4-BE49-F238E27FC236}">
-                <a16:creationId xmlns:a16="http://schemas.microsoft.com/office/drawing/2014/main" id="{F1443E2B-99B0-4350-B62C-5AF845D3C1DA}"/>
+                <a16:creationId xmlns:a16="http://schemas.microsoft.com/office/drawing/2014/main" id="{F485C86B-A8E6-4C0C-AE48-791B0F9CEC5D}"/>
               </a:ext>
             </a:extLst>
           </p:cNvPr>
@@ -7219,7 +7219,7 @@
     </p:spTree>
     <p:extLst>
       <p:ext uri="{BB962C8B-B14F-4D97-AF65-F5344CB8AC3E}">
-        <p14:creationId xmlns:p14="http://schemas.microsoft.com/office/powerpoint/2010/main" val="694528606"/>
+        <p14:creationId xmlns:p14="http://schemas.microsoft.com/office/powerpoint/2010/main" val="1498800399"/>
       </p:ext>
     </p:extLst>
   </p:cSld>
@@ -7250,7 +7250,7 @@
           <p:cNvPr id="17" name="">
             <a:extLst xmlns:a="http://schemas.openxmlformats.org/drawingml/2006/main">
               <a:ext uri="{FF2B5EF4-FFF2-40B4-BE49-F238E27FC236}">
-                <a16:creationId xmlns:a16="http://schemas.microsoft.com/office/drawing/2014/main" id="{876A72FC-5FA8-4016-A0C7-8E36B41698CC}"/>
+                <a16:creationId xmlns:a16="http://schemas.microsoft.com/office/drawing/2014/main" id="{C9E43876-F50B-4098-938A-4606513D18B3}"/>
               </a:ext>
             </a:extLst>
           </p:cNvPr>
@@ -7318,7 +7318,7 @@
           <p:cNvPr id="2" name="">
             <a:extLst xmlns:a="http://schemas.openxmlformats.org/drawingml/2006/main">
               <a:ext uri="{FF2B5EF4-FFF2-40B4-BE49-F238E27FC236}">
-                <a16:creationId xmlns:a16="http://schemas.microsoft.com/office/drawing/2014/main" id="{E57BD5A5-321F-4D5F-9F49-956D3F1AB069}"/>
+                <a16:creationId xmlns:a16="http://schemas.microsoft.com/office/drawing/2014/main" id="{38C433B8-617E-4BBD-A0C2-7FF1EDBE6BDA}"/>
               </a:ext>
             </a:extLst>
           </p:cNvPr>
@@ -7386,7 +7386,7 @@
           <p:cNvPr id="3" name="">
             <a:extLst xmlns:a="http://schemas.openxmlformats.org/drawingml/2006/main">
               <a:ext uri="{FF2B5EF4-FFF2-40B4-BE49-F238E27FC236}">
-                <a16:creationId xmlns:a16="http://schemas.microsoft.com/office/drawing/2014/main" id="{A728E3EE-516D-4A48-88A4-6F77314AD954}"/>
+                <a16:creationId xmlns:a16="http://schemas.microsoft.com/office/drawing/2014/main" id="{5103640C-677E-4FDC-9F71-709AF30E39E2}"/>
               </a:ext>
             </a:extLst>
           </p:cNvPr>
@@ -7416,7 +7416,7 @@
           <p:cNvPr id="4" name="">
             <a:extLst xmlns:a="http://schemas.openxmlformats.org/drawingml/2006/main">
               <a:ext uri="{FF2B5EF4-FFF2-40B4-BE49-F238E27FC236}">
-                <a16:creationId xmlns:a16="http://schemas.microsoft.com/office/drawing/2014/main" id="{C09AB041-D740-4289-B7C2-607D55FCAF87}"/>
+                <a16:creationId xmlns:a16="http://schemas.microsoft.com/office/drawing/2014/main" id="{D8DD3077-A1A3-4773-8539-F0165BA911D6}"/>
               </a:ext>
             </a:extLst>
           </p:cNvPr>
@@ -7484,7 +7484,7 @@
           <p:cNvPr id="5" name="">
             <a:extLst xmlns:a="http://schemas.openxmlformats.org/drawingml/2006/main">
               <a:ext uri="{FF2B5EF4-FFF2-40B4-BE49-F238E27FC236}">
-                <a16:creationId xmlns:a16="http://schemas.microsoft.com/office/drawing/2014/main" id="{D43325A9-FFF0-46F2-887A-4E8B94401322}"/>
+                <a16:creationId xmlns:a16="http://schemas.microsoft.com/office/drawing/2014/main" id="{E61419AA-4F87-4CE9-BC26-40FCD8E17F8D}"/>
               </a:ext>
             </a:extLst>
           </p:cNvPr>
@@ -7552,7 +7552,7 @@
           <p:cNvPr id="6" name="">
             <a:extLst xmlns:a="http://schemas.openxmlformats.org/drawingml/2006/main">
               <a:ext uri="{FF2B5EF4-FFF2-40B4-BE49-F238E27FC236}">
-                <a16:creationId xmlns:a16="http://schemas.microsoft.com/office/drawing/2014/main" id="{47F376A3-5489-4AFE-B30C-87140DCBD282}"/>
+                <a16:creationId xmlns:a16="http://schemas.microsoft.com/office/drawing/2014/main" id="{8B36F841-1A99-4D99-899F-256BEB7F63E0}"/>
               </a:ext>
             </a:extLst>
           </p:cNvPr>
@@ -7620,7 +7620,7 @@
           <p:cNvPr id="7" name="">
             <a:extLst xmlns:a="http://schemas.openxmlformats.org/drawingml/2006/main">
               <a:ext uri="{FF2B5EF4-FFF2-40B4-BE49-F238E27FC236}">
-                <a16:creationId xmlns:a16="http://schemas.microsoft.com/office/drawing/2014/main" id="{0AF86478-FEE0-4CBF-9A07-8849953DE71D}"/>
+                <a16:creationId xmlns:a16="http://schemas.microsoft.com/office/drawing/2014/main" id="{2BE4A5A7-8DC0-42CE-B1A8-5EFD6738F164}"/>
               </a:ext>
             </a:extLst>
           </p:cNvPr>
@@ -7688,7 +7688,7 @@
           <p:cNvPr id="8" name="">
             <a:extLst xmlns:a="http://schemas.openxmlformats.org/drawingml/2006/main">
               <a:ext uri="{FF2B5EF4-FFF2-40B4-BE49-F238E27FC236}">
-                <a16:creationId xmlns:a16="http://schemas.microsoft.com/office/drawing/2014/main" id="{A6581472-3528-44D1-8B57-B7F9BF7C2641}"/>
+                <a16:creationId xmlns:a16="http://schemas.microsoft.com/office/drawing/2014/main" id="{D4753005-CAFD-4DAD-BE27-8998ADF73E60}"/>
               </a:ext>
             </a:extLst>
           </p:cNvPr>
@@ -7779,7 +7779,7 @@
           <p:cNvPr id="9" name="">
             <a:extLst xmlns:a="http://schemas.openxmlformats.org/drawingml/2006/main">
               <a:ext uri="{FF2B5EF4-FFF2-40B4-BE49-F238E27FC236}">
-                <a16:creationId xmlns:a16="http://schemas.microsoft.com/office/drawing/2014/main" id="{C2D72A2E-21C9-4A24-B3F8-C799C7576BD3}"/>
+                <a16:creationId xmlns:a16="http://schemas.microsoft.com/office/drawing/2014/main" id="{EB2464C3-46D7-4817-A850-462D4BA8EE09}"/>
               </a:ext>
             </a:extLst>
           </p:cNvPr>
@@ -7809,7 +7809,7 @@
           <p:cNvPr id="10" name="">
             <a:extLst xmlns:a="http://schemas.openxmlformats.org/drawingml/2006/main">
               <a:ext uri="{FF2B5EF4-FFF2-40B4-BE49-F238E27FC236}">
-                <a16:creationId xmlns:a16="http://schemas.microsoft.com/office/drawing/2014/main" id="{C1B2D958-2D2A-4A4B-BF62-7E0837E15F9B}"/>
+                <a16:creationId xmlns:a16="http://schemas.microsoft.com/office/drawing/2014/main" id="{B10392B1-9486-4FE2-9EDA-48F163D62EB9}"/>
               </a:ext>
             </a:extLst>
           </p:cNvPr>
@@ -7877,7 +7877,7 @@
           <p:cNvPr id="11" name="">
             <a:extLst xmlns:a="http://schemas.openxmlformats.org/drawingml/2006/main">
               <a:ext uri="{FF2B5EF4-FFF2-40B4-BE49-F238E27FC236}">
-                <a16:creationId xmlns:a16="http://schemas.microsoft.com/office/drawing/2014/main" id="{8751AD0D-CCA7-4613-976A-890461102BC7}"/>
+                <a16:creationId xmlns:a16="http://schemas.microsoft.com/office/drawing/2014/main" id="{59BA5E92-676A-4772-9557-9E0827249DE7}"/>
               </a:ext>
             </a:extLst>
           </p:cNvPr>
@@ -7945,7 +7945,7 @@
           <p:cNvPr id="12" name="">
             <a:extLst xmlns:a="http://schemas.openxmlformats.org/drawingml/2006/main">
               <a:ext uri="{FF2B5EF4-FFF2-40B4-BE49-F238E27FC236}">
-                <a16:creationId xmlns:a16="http://schemas.microsoft.com/office/drawing/2014/main" id="{40428B02-522C-44E2-9148-290772ED59C2}"/>
+                <a16:creationId xmlns:a16="http://schemas.microsoft.com/office/drawing/2014/main" id="{45D26565-FE59-42B6-BF0F-DDF925DC938D}"/>
               </a:ext>
             </a:extLst>
           </p:cNvPr>
@@ -8036,7 +8036,7 @@
           <p:cNvPr id="13" name="">
             <a:extLst xmlns:a="http://schemas.openxmlformats.org/drawingml/2006/main">
               <a:ext uri="{FF2B5EF4-FFF2-40B4-BE49-F238E27FC236}">
-                <a16:creationId xmlns:a16="http://schemas.microsoft.com/office/drawing/2014/main" id="{A0ABA622-0457-4B17-B779-90C80BE4EE51}"/>
+                <a16:creationId xmlns:a16="http://schemas.microsoft.com/office/drawing/2014/main" id="{414EDB78-601C-4A91-982B-B3C6B84E3DF8}"/>
               </a:ext>
             </a:extLst>
           </p:cNvPr>
@@ -8066,7 +8066,7 @@
           <p:cNvPr id="14" name="">
             <a:extLst xmlns:a="http://schemas.openxmlformats.org/drawingml/2006/main">
               <a:ext uri="{FF2B5EF4-FFF2-40B4-BE49-F238E27FC236}">
-                <a16:creationId xmlns:a16="http://schemas.microsoft.com/office/drawing/2014/main" id="{45950506-C7DF-4B92-94A0-E0EF6E0AC841}"/>
+                <a16:creationId xmlns:a16="http://schemas.microsoft.com/office/drawing/2014/main" id="{3DB0D69A-B1F5-4096-B109-A680164A2FB8}"/>
               </a:ext>
             </a:extLst>
           </p:cNvPr>
@@ -8134,7 +8134,7 @@
           <p:cNvPr id="15" name="">
             <a:extLst xmlns:a="http://schemas.openxmlformats.org/drawingml/2006/main">
               <a:ext uri="{FF2B5EF4-FFF2-40B4-BE49-F238E27FC236}">
-                <a16:creationId xmlns:a16="http://schemas.microsoft.com/office/drawing/2014/main" id="{BCC572BD-4917-4AA6-A7FF-A070D46BD9F2}"/>
+                <a16:creationId xmlns:a16="http://schemas.microsoft.com/office/drawing/2014/main" id="{065693AC-7EF5-4578-BD51-11A12E5622E5}"/>
               </a:ext>
             </a:extLst>
           </p:cNvPr>
@@ -8202,7 +8202,7 @@
           <p:cNvPr id="16" name="">
             <a:extLst xmlns:a="http://schemas.openxmlformats.org/drawingml/2006/main">
               <a:ext uri="{FF2B5EF4-FFF2-40B4-BE49-F238E27FC236}">
-                <a16:creationId xmlns:a16="http://schemas.microsoft.com/office/drawing/2014/main" id="{8DCFBCC0-B309-418C-81C4-E13929B80EDB}"/>
+                <a16:creationId xmlns:a16="http://schemas.microsoft.com/office/drawing/2014/main" id="{361761E1-DB86-47CC-988D-4FC19B1A5083}"/>
               </a:ext>
             </a:extLst>
           </p:cNvPr>
@@ -8268,7 +8268,7 @@
     </p:spTree>
     <p:extLst>
       <p:ext uri="{BB962C8B-B14F-4D97-AF65-F5344CB8AC3E}">
-        <p14:creationId xmlns:p14="http://schemas.microsoft.com/office/powerpoint/2010/main" val="1220962137"/>
+        <p14:creationId xmlns:p14="http://schemas.microsoft.com/office/powerpoint/2010/main" val="853934968"/>
       </p:ext>
     </p:extLst>
   </p:cSld>
@@ -8299,7 +8299,7 @@
           <p:cNvPr id="19" name="">
             <a:extLst xmlns:a="http://schemas.openxmlformats.org/drawingml/2006/main">
               <a:ext uri="{FF2B5EF4-FFF2-40B4-BE49-F238E27FC236}">
-                <a16:creationId xmlns:a16="http://schemas.microsoft.com/office/drawing/2014/main" id="{7AE4059D-ED8F-4317-AAFD-F5FB77094CCC}"/>
+                <a16:creationId xmlns:a16="http://schemas.microsoft.com/office/drawing/2014/main" id="{AA6A1AA6-2792-482B-8608-5C4FFD319991}"/>
               </a:ext>
             </a:extLst>
           </p:cNvPr>
@@ -8367,7 +8367,7 @@
           <p:cNvPr id="2" name="">
             <a:extLst xmlns:a="http://schemas.openxmlformats.org/drawingml/2006/main">
               <a:ext uri="{FF2B5EF4-FFF2-40B4-BE49-F238E27FC236}">
-                <a16:creationId xmlns:a16="http://schemas.microsoft.com/office/drawing/2014/main" id="{3B319ED3-2CAF-42E7-954F-B9B5E8A59BD0}"/>
+                <a16:creationId xmlns:a16="http://schemas.microsoft.com/office/drawing/2014/main" id="{6EA2A2AD-D16D-49E1-A770-D4E2F3F43B35}"/>
               </a:ext>
             </a:extLst>
           </p:cNvPr>
@@ -8435,7 +8435,7 @@
           <p:cNvPr id="3" name="">
             <a:extLst xmlns:a="http://schemas.openxmlformats.org/drawingml/2006/main">
               <a:ext uri="{FF2B5EF4-FFF2-40B4-BE49-F238E27FC236}">
-                <a16:creationId xmlns:a16="http://schemas.microsoft.com/office/drawing/2014/main" id="{A8A8986C-3FD0-4B53-B8A1-954C77B19AE5}"/>
+                <a16:creationId xmlns:a16="http://schemas.microsoft.com/office/drawing/2014/main" id="{3C4DB2D4-575A-4CD5-98B5-A472DA5F0E73}"/>
               </a:ext>
             </a:extLst>
           </p:cNvPr>
@@ -8465,7 +8465,7 @@
           <p:cNvPr id="4" name="">
             <a:extLst xmlns:a="http://schemas.openxmlformats.org/drawingml/2006/main">
               <a:ext uri="{FF2B5EF4-FFF2-40B4-BE49-F238E27FC236}">
-                <a16:creationId xmlns:a16="http://schemas.microsoft.com/office/drawing/2014/main" id="{D18FAEF7-F4B3-4493-8EDA-2354986199F3}"/>
+                <a16:creationId xmlns:a16="http://schemas.microsoft.com/office/drawing/2014/main" id="{60989888-0995-4225-8063-026E675FADA1}"/>
               </a:ext>
             </a:extLst>
           </p:cNvPr>
@@ -8533,7 +8533,7 @@
           <p:cNvPr id="5" name="">
             <a:extLst xmlns:a="http://schemas.openxmlformats.org/drawingml/2006/main">
               <a:ext uri="{FF2B5EF4-FFF2-40B4-BE49-F238E27FC236}">
-                <a16:creationId xmlns:a16="http://schemas.microsoft.com/office/drawing/2014/main" id="{0D849FEA-0CD8-4654-88FE-F3D6E88A5DCC}"/>
+                <a16:creationId xmlns:a16="http://schemas.microsoft.com/office/drawing/2014/main" id="{1E578271-B26F-4808-BD8C-E3953821F8E1}"/>
               </a:ext>
             </a:extLst>
           </p:cNvPr>
@@ -8601,7 +8601,7 @@
           <p:cNvPr id="6" name="">
             <a:extLst xmlns:a="http://schemas.openxmlformats.org/drawingml/2006/main">
               <a:ext uri="{FF2B5EF4-FFF2-40B4-BE49-F238E27FC236}">
-                <a16:creationId xmlns:a16="http://schemas.microsoft.com/office/drawing/2014/main" id="{703E7932-367A-49C6-AF02-8A4111A1147B}"/>
+                <a16:creationId xmlns:a16="http://schemas.microsoft.com/office/drawing/2014/main" id="{456D1853-6795-4A16-BE28-94310EE7C559}"/>
               </a:ext>
             </a:extLst>
           </p:cNvPr>
@@ -8669,7 +8669,7 @@
           <p:cNvPr id="7" name="">
             <a:extLst xmlns:a="http://schemas.openxmlformats.org/drawingml/2006/main">
               <a:ext uri="{FF2B5EF4-FFF2-40B4-BE49-F238E27FC236}">
-                <a16:creationId xmlns:a16="http://schemas.microsoft.com/office/drawing/2014/main" id="{C5A6EC44-250A-4F78-98C1-68CCE721E7B4}"/>
+                <a16:creationId xmlns:a16="http://schemas.microsoft.com/office/drawing/2014/main" id="{596D38A5-DDD0-477F-8895-F46937F7725B}"/>
               </a:ext>
             </a:extLst>
           </p:cNvPr>
@@ -8737,7 +8737,7 @@
           <p:cNvPr id="8" name="">
             <a:extLst xmlns:a="http://schemas.openxmlformats.org/drawingml/2006/main">
               <a:ext uri="{FF2B5EF4-FFF2-40B4-BE49-F238E27FC236}">
-                <a16:creationId xmlns:a16="http://schemas.microsoft.com/office/drawing/2014/main" id="{EE0A2C02-FB34-4FF9-87FA-95A59C6785BA}"/>
+                <a16:creationId xmlns:a16="http://schemas.microsoft.com/office/drawing/2014/main" id="{0C13A911-229D-4C47-B8CD-B7951E07D280}"/>
               </a:ext>
             </a:extLst>
           </p:cNvPr>
@@ -8767,7 +8767,7 @@
           <p:cNvPr id="9" name="">
             <a:extLst xmlns:a="http://schemas.openxmlformats.org/drawingml/2006/main">
               <a:ext uri="{FF2B5EF4-FFF2-40B4-BE49-F238E27FC236}">
-                <a16:creationId xmlns:a16="http://schemas.microsoft.com/office/drawing/2014/main" id="{8DF6416C-0C46-4F4D-8901-B959515C9A47}"/>
+                <a16:creationId xmlns:a16="http://schemas.microsoft.com/office/drawing/2014/main" id="{88D28234-F182-416B-AC61-EC221744B2C5}"/>
               </a:ext>
             </a:extLst>
           </p:cNvPr>
@@ -8920,7 +8920,7 @@
           <p:cNvPr id="10" name="">
             <a:extLst xmlns:a="http://schemas.openxmlformats.org/drawingml/2006/main">
               <a:ext uri="{FF2B5EF4-FFF2-40B4-BE49-F238E27FC236}">
-                <a16:creationId xmlns:a16="http://schemas.microsoft.com/office/drawing/2014/main" id="{8CB476C1-A354-4D57-B975-FC4504FF2362}"/>
+                <a16:creationId xmlns:a16="http://schemas.microsoft.com/office/drawing/2014/main" id="{07D70004-2CF0-4C8D-BDB7-6D27C9310957}"/>
               </a:ext>
             </a:extLst>
           </p:cNvPr>
@@ -8988,7 +8988,7 @@
           <p:cNvPr id="11" name="">
             <a:extLst xmlns:a="http://schemas.openxmlformats.org/drawingml/2006/main">
               <a:ext uri="{FF2B5EF4-FFF2-40B4-BE49-F238E27FC236}">
-                <a16:creationId xmlns:a16="http://schemas.microsoft.com/office/drawing/2014/main" id="{5AAE6F26-F7B1-4C6C-AE14-A5883A1A706D}"/>
+                <a16:creationId xmlns:a16="http://schemas.microsoft.com/office/drawing/2014/main" id="{DEB78C86-1B6E-47AF-869F-D478A64BC744}"/>
               </a:ext>
             </a:extLst>
           </p:cNvPr>
@@ -9056,7 +9056,7 @@
           <p:cNvPr id="12" name="">
             <a:extLst xmlns:a="http://schemas.openxmlformats.org/drawingml/2006/main">
               <a:ext uri="{FF2B5EF4-FFF2-40B4-BE49-F238E27FC236}">
-                <a16:creationId xmlns:a16="http://schemas.microsoft.com/office/drawing/2014/main" id="{96FEDE3D-E461-47BC-91CA-EFED25430115}"/>
+                <a16:creationId xmlns:a16="http://schemas.microsoft.com/office/drawing/2014/main" id="{B6B40B6B-C302-4832-9274-AE4C55B3468F}"/>
               </a:ext>
             </a:extLst>
           </p:cNvPr>
@@ -9124,7 +9124,7 @@
           <p:cNvPr id="13" name="">
             <a:extLst xmlns:a="http://schemas.openxmlformats.org/drawingml/2006/main">
               <a:ext uri="{FF2B5EF4-FFF2-40B4-BE49-F238E27FC236}">
-                <a16:creationId xmlns:a16="http://schemas.microsoft.com/office/drawing/2014/main" id="{B3BCC74B-242B-482A-A2FA-1B1537E5CEED}"/>
+                <a16:creationId xmlns:a16="http://schemas.microsoft.com/office/drawing/2014/main" id="{FDF3356C-2A27-496E-93FF-F80BA6B1D6E6}"/>
               </a:ext>
             </a:extLst>
           </p:cNvPr>
@@ -9192,7 +9192,7 @@
           <p:cNvPr id="14" name="">
             <a:extLst xmlns:a="http://schemas.openxmlformats.org/drawingml/2006/main">
               <a:ext uri="{FF2B5EF4-FFF2-40B4-BE49-F238E27FC236}">
-                <a16:creationId xmlns:a16="http://schemas.microsoft.com/office/drawing/2014/main" id="{D5475B94-9F53-4A85-93D8-FC5F2B9BCC3D}"/>
+                <a16:creationId xmlns:a16="http://schemas.microsoft.com/office/drawing/2014/main" id="{6D50FAD0-9148-480F-A207-D022E398F1B4}"/>
               </a:ext>
             </a:extLst>
           </p:cNvPr>
@@ -9260,7 +9260,7 @@
           <p:cNvPr id="15" name="">
             <a:extLst xmlns:a="http://schemas.openxmlformats.org/drawingml/2006/main">
               <a:ext uri="{FF2B5EF4-FFF2-40B4-BE49-F238E27FC236}">
-                <a16:creationId xmlns:a16="http://schemas.microsoft.com/office/drawing/2014/main" id="{8EDF4603-0FCC-46C2-88F4-2B2A7A7C6FFE}"/>
+                <a16:creationId xmlns:a16="http://schemas.microsoft.com/office/drawing/2014/main" id="{0935706E-C032-4D49-8DE0-41FC6EB6FB6D}"/>
               </a:ext>
             </a:extLst>
           </p:cNvPr>
@@ -9328,7 +9328,7 @@
           <p:cNvPr id="16" name="">
             <a:extLst xmlns:a="http://schemas.openxmlformats.org/drawingml/2006/main">
               <a:ext uri="{FF2B5EF4-FFF2-40B4-BE49-F238E27FC236}">
-                <a16:creationId xmlns:a16="http://schemas.microsoft.com/office/drawing/2014/main" id="{434E76E5-57B0-44A8-BD1B-F656D481BFA5}"/>
+                <a16:creationId xmlns:a16="http://schemas.microsoft.com/office/drawing/2014/main" id="{68318D42-C9E5-42A8-8077-FF5520D839C1}"/>
               </a:ext>
             </a:extLst>
           </p:cNvPr>
@@ -9396,7 +9396,7 @@
           <p:cNvPr id="17" name="">
             <a:extLst xmlns:a="http://schemas.openxmlformats.org/drawingml/2006/main">
               <a:ext uri="{FF2B5EF4-FFF2-40B4-BE49-F238E27FC236}">
-                <a16:creationId xmlns:a16="http://schemas.microsoft.com/office/drawing/2014/main" id="{0380E479-5B93-4CD9-AE6F-D4EE8D1FDFCB}"/>
+                <a16:creationId xmlns:a16="http://schemas.microsoft.com/office/drawing/2014/main" id="{37B11B83-CCA2-4C2C-B309-1A91AF5E2720}"/>
               </a:ext>
             </a:extLst>
           </p:cNvPr>
@@ -9464,7 +9464,7 @@
           <p:cNvPr id="18" name="">
             <a:extLst xmlns:a="http://schemas.openxmlformats.org/drawingml/2006/main">
               <a:ext uri="{FF2B5EF4-FFF2-40B4-BE49-F238E27FC236}">
-                <a16:creationId xmlns:a16="http://schemas.microsoft.com/office/drawing/2014/main" id="{1949C4BF-F555-4069-B1A9-09943CD70F3C}"/>
+                <a16:creationId xmlns:a16="http://schemas.microsoft.com/office/drawing/2014/main" id="{8B6F629F-F4A7-445D-B414-B475754ACBA7}"/>
               </a:ext>
             </a:extLst>
           </p:cNvPr>
@@ -9530,7 +9530,7 @@
     </p:spTree>
     <p:extLst>
       <p:ext uri="{BB962C8B-B14F-4D97-AF65-F5344CB8AC3E}">
-        <p14:creationId xmlns:p14="http://schemas.microsoft.com/office/powerpoint/2010/main" val="396999049"/>
+        <p14:creationId xmlns:p14="http://schemas.microsoft.com/office/powerpoint/2010/main" val="1964877369"/>
       </p:ext>
     </p:extLst>
   </p:cSld>
@@ -9561,7 +9561,7 @@
           <p:cNvPr id="29" name="">
             <a:extLst xmlns:a="http://schemas.openxmlformats.org/drawingml/2006/main">
               <a:ext uri="{FF2B5EF4-FFF2-40B4-BE49-F238E27FC236}">
-                <a16:creationId xmlns:a16="http://schemas.microsoft.com/office/drawing/2014/main" id="{060025C2-1A7E-482C-B23F-7D919FE5EE78}"/>
+                <a16:creationId xmlns:a16="http://schemas.microsoft.com/office/drawing/2014/main" id="{5868EE59-BC5D-4D15-A769-282475075242}"/>
               </a:ext>
             </a:extLst>
           </p:cNvPr>
@@ -9629,7 +9629,7 @@
           <p:cNvPr id="2" name="">
             <a:extLst xmlns:a="http://schemas.openxmlformats.org/drawingml/2006/main">
               <a:ext uri="{FF2B5EF4-FFF2-40B4-BE49-F238E27FC236}">
-                <a16:creationId xmlns:a16="http://schemas.microsoft.com/office/drawing/2014/main" id="{8227A2EA-22E3-4E5A-BF77-5A47D59FF280}"/>
+                <a16:creationId xmlns:a16="http://schemas.microsoft.com/office/drawing/2014/main" id="{40BEADFF-6E1A-4BBD-8278-BD71BB959104}"/>
               </a:ext>
             </a:extLst>
           </p:cNvPr>
@@ -9697,7 +9697,7 @@
           <p:cNvPr id="3" name="">
             <a:extLst xmlns:a="http://schemas.openxmlformats.org/drawingml/2006/main">
               <a:ext uri="{FF2B5EF4-FFF2-40B4-BE49-F238E27FC236}">
-                <a16:creationId xmlns:a16="http://schemas.microsoft.com/office/drawing/2014/main" id="{0DB3E3C6-E83E-4BED-951E-4E5499ACB664}"/>
+                <a16:creationId xmlns:a16="http://schemas.microsoft.com/office/drawing/2014/main" id="{8B12F435-183F-474E-9F3F-A91CBFA32543}"/>
               </a:ext>
             </a:extLst>
           </p:cNvPr>
@@ -9727,7 +9727,7 @@
           <p:cNvPr id="4" name="">
             <a:extLst xmlns:a="http://schemas.openxmlformats.org/drawingml/2006/main">
               <a:ext uri="{FF2B5EF4-FFF2-40B4-BE49-F238E27FC236}">
-                <a16:creationId xmlns:a16="http://schemas.microsoft.com/office/drawing/2014/main" id="{0986E051-6E9F-4EB7-BFF0-ECFAF34C9C22}"/>
+                <a16:creationId xmlns:a16="http://schemas.microsoft.com/office/drawing/2014/main" id="{5B7DD6E6-7794-456F-87A0-39816542D760}"/>
               </a:ext>
             </a:extLst>
           </p:cNvPr>
@@ -9795,7 +9795,7 @@
           <p:cNvPr id="5" name="">
             <a:extLst xmlns:a="http://schemas.openxmlformats.org/drawingml/2006/main">
               <a:ext uri="{FF2B5EF4-FFF2-40B4-BE49-F238E27FC236}">
-                <a16:creationId xmlns:a16="http://schemas.microsoft.com/office/drawing/2014/main" id="{A4E0FEA5-8790-4D27-A5FD-F551022AF1D5}"/>
+                <a16:creationId xmlns:a16="http://schemas.microsoft.com/office/drawing/2014/main" id="{5D999CEA-5ECB-4149-8958-38E78D111E70}"/>
               </a:ext>
             </a:extLst>
           </p:cNvPr>
@@ -9863,7 +9863,7 @@
           <p:cNvPr id="6" name="">
             <a:extLst xmlns:a="http://schemas.openxmlformats.org/drawingml/2006/main">
               <a:ext uri="{FF2B5EF4-FFF2-40B4-BE49-F238E27FC236}">
-                <a16:creationId xmlns:a16="http://schemas.microsoft.com/office/drawing/2014/main" id="{D5B3EEA8-594F-4AA3-9C50-900F393D617C}"/>
+                <a16:creationId xmlns:a16="http://schemas.microsoft.com/office/drawing/2014/main" id="{3AD9001C-C60A-4F4E-91E9-11CEAD6168F9}"/>
               </a:ext>
             </a:extLst>
           </p:cNvPr>
@@ -9897,7 +9897,7 @@
           <p:cNvPr id="7" name="">
             <a:extLst xmlns:a="http://schemas.openxmlformats.org/drawingml/2006/main">
               <a:ext uri="{FF2B5EF4-FFF2-40B4-BE49-F238E27FC236}">
-                <a16:creationId xmlns:a16="http://schemas.microsoft.com/office/drawing/2014/main" id="{805F05D9-2389-4668-84D8-C3C856569A26}"/>
+                <a16:creationId xmlns:a16="http://schemas.microsoft.com/office/drawing/2014/main" id="{A9BCDFE9-CC48-4FF8-BF33-932005C3C72E}"/>
               </a:ext>
             </a:extLst>
           </p:cNvPr>
@@ -9965,7 +9965,7 @@
           <p:cNvPr id="8" name="">
             <a:extLst xmlns:a="http://schemas.openxmlformats.org/drawingml/2006/main">
               <a:ext uri="{FF2B5EF4-FFF2-40B4-BE49-F238E27FC236}">
-                <a16:creationId xmlns:a16="http://schemas.microsoft.com/office/drawing/2014/main" id="{10C74E59-26EB-4135-81C8-E206D04948CA}"/>
+                <a16:creationId xmlns:a16="http://schemas.microsoft.com/office/drawing/2014/main" id="{22F3CF4D-42E5-4291-940B-E29EB1269749}"/>
               </a:ext>
             </a:extLst>
           </p:cNvPr>
@@ -10056,7 +10056,7 @@
           <p:cNvPr id="9" name="">
             <a:extLst xmlns:a="http://schemas.openxmlformats.org/drawingml/2006/main">
               <a:ext uri="{FF2B5EF4-FFF2-40B4-BE49-F238E27FC236}">
-                <a16:creationId xmlns:a16="http://schemas.microsoft.com/office/drawing/2014/main" id="{25341505-5CA4-4C40-B5A3-C853B2E1E1F4}"/>
+                <a16:creationId xmlns:a16="http://schemas.microsoft.com/office/drawing/2014/main" id="{B711D198-F219-45F8-9E27-A0E2B180F2EF}"/>
               </a:ext>
             </a:extLst>
           </p:cNvPr>
@@ -10090,7 +10090,7 @@
           <p:cNvPr id="10" name="">
             <a:extLst xmlns:a="http://schemas.openxmlformats.org/drawingml/2006/main">
               <a:ext uri="{FF2B5EF4-FFF2-40B4-BE49-F238E27FC236}">
-                <a16:creationId xmlns:a16="http://schemas.microsoft.com/office/drawing/2014/main" id="{1FED1901-F609-45E4-AED8-3BD3876867B0}"/>
+                <a16:creationId xmlns:a16="http://schemas.microsoft.com/office/drawing/2014/main" id="{00F600B6-495F-4531-BDDF-2D7754F6E3BC}"/>
               </a:ext>
             </a:extLst>
           </p:cNvPr>
@@ -10158,7 +10158,7 @@
           <p:cNvPr id="11" name="">
             <a:extLst xmlns:a="http://schemas.openxmlformats.org/drawingml/2006/main">
               <a:ext uri="{FF2B5EF4-FFF2-40B4-BE49-F238E27FC236}">
-                <a16:creationId xmlns:a16="http://schemas.microsoft.com/office/drawing/2014/main" id="{D95EFCD0-1A9D-4DA0-835C-F8B860D23016}"/>
+                <a16:creationId xmlns:a16="http://schemas.microsoft.com/office/drawing/2014/main" id="{A24FF55E-3F44-474B-ADAC-233FFBD7B18E}"/>
               </a:ext>
             </a:extLst>
           </p:cNvPr>
@@ -10249,7 +10249,7 @@
           <p:cNvPr id="12" name="">
             <a:extLst xmlns:a="http://schemas.openxmlformats.org/drawingml/2006/main">
               <a:ext uri="{FF2B5EF4-FFF2-40B4-BE49-F238E27FC236}">
-                <a16:creationId xmlns:a16="http://schemas.microsoft.com/office/drawing/2014/main" id="{10F0E3EC-279B-48D0-938F-C7D860A36910}"/>
+                <a16:creationId xmlns:a16="http://schemas.microsoft.com/office/drawing/2014/main" id="{1BA030CA-6561-43A1-A95F-840543B7A2AE}"/>
               </a:ext>
             </a:extLst>
           </p:cNvPr>
@@ -10283,7 +10283,7 @@
           <p:cNvPr id="13" name="">
             <a:extLst xmlns:a="http://schemas.openxmlformats.org/drawingml/2006/main">
               <a:ext uri="{FF2B5EF4-FFF2-40B4-BE49-F238E27FC236}">
-                <a16:creationId xmlns:a16="http://schemas.microsoft.com/office/drawing/2014/main" id="{29785E9D-1AC6-4452-90EF-BC0B5EF384A6}"/>
+                <a16:creationId xmlns:a16="http://schemas.microsoft.com/office/drawing/2014/main" id="{EFE31472-852C-47C6-BB30-CF66DCFA5CB9}"/>
               </a:ext>
             </a:extLst>
           </p:cNvPr>
@@ -10351,7 +10351,7 @@
           <p:cNvPr id="14" name="">
             <a:extLst xmlns:a="http://schemas.openxmlformats.org/drawingml/2006/main">
               <a:ext uri="{FF2B5EF4-FFF2-40B4-BE49-F238E27FC236}">
-                <a16:creationId xmlns:a16="http://schemas.microsoft.com/office/drawing/2014/main" id="{B5C9B098-9B4E-4D5C-9710-9EE2E212BF18}"/>
+                <a16:creationId xmlns:a16="http://schemas.microsoft.com/office/drawing/2014/main" id="{2E3F5435-06AF-4599-AE9C-92349DFDB2EB}"/>
               </a:ext>
             </a:extLst>
           </p:cNvPr>
@@ -10442,7 +10442,7 @@
           <p:cNvPr id="15" name="">
             <a:extLst xmlns:a="http://schemas.openxmlformats.org/drawingml/2006/main">
               <a:ext uri="{FF2B5EF4-FFF2-40B4-BE49-F238E27FC236}">
-                <a16:creationId xmlns:a16="http://schemas.microsoft.com/office/drawing/2014/main" id="{41F6363B-54F4-4EE0-A84D-D83CEDD2BF7E}"/>
+                <a16:creationId xmlns:a16="http://schemas.microsoft.com/office/drawing/2014/main" id="{E7A8C2D0-7229-487F-A0F8-2148EFEE4613}"/>
               </a:ext>
             </a:extLst>
           </p:cNvPr>
@@ -10476,7 +10476,7 @@
           <p:cNvPr id="16" name="">
             <a:extLst xmlns:a="http://schemas.openxmlformats.org/drawingml/2006/main">
               <a:ext uri="{FF2B5EF4-FFF2-40B4-BE49-F238E27FC236}">
-                <a16:creationId xmlns:a16="http://schemas.microsoft.com/office/drawing/2014/main" id="{BC5C6D2E-514C-4E1E-AA05-3FE1E392B4C5}"/>
+                <a16:creationId xmlns:a16="http://schemas.microsoft.com/office/drawing/2014/main" id="{2531CDC0-9898-4645-95BD-18D93E5CF4F1}"/>
               </a:ext>
             </a:extLst>
           </p:cNvPr>
@@ -10544,7 +10544,7 @@
           <p:cNvPr id="17" name="">
             <a:extLst xmlns:a="http://schemas.openxmlformats.org/drawingml/2006/main">
               <a:ext uri="{FF2B5EF4-FFF2-40B4-BE49-F238E27FC236}">
-                <a16:creationId xmlns:a16="http://schemas.microsoft.com/office/drawing/2014/main" id="{435A6229-D693-4169-BB85-FFEE8C4F5FDB}"/>
+                <a16:creationId xmlns:a16="http://schemas.microsoft.com/office/drawing/2014/main" id="{FBAB5D59-5276-403D-8969-7281E12D5BA3}"/>
               </a:ext>
             </a:extLst>
           </p:cNvPr>
@@ -10635,7 +10635,7 @@
           <p:cNvPr id="18" name="">
             <a:extLst xmlns:a="http://schemas.openxmlformats.org/drawingml/2006/main">
               <a:ext uri="{FF2B5EF4-FFF2-40B4-BE49-F238E27FC236}">
-                <a16:creationId xmlns:a16="http://schemas.microsoft.com/office/drawing/2014/main" id="{F23BD6C3-07B0-42EA-B86C-F89DEC4EF5A3}"/>
+                <a16:creationId xmlns:a16="http://schemas.microsoft.com/office/drawing/2014/main" id="{CF5E962B-53DB-4B2A-90B1-0941B1248A35}"/>
               </a:ext>
             </a:extLst>
           </p:cNvPr>
@@ -10669,7 +10669,7 @@
           <p:cNvPr id="19" name="">
             <a:extLst xmlns:a="http://schemas.openxmlformats.org/drawingml/2006/main">
               <a:ext uri="{FF2B5EF4-FFF2-40B4-BE49-F238E27FC236}">
-                <a16:creationId xmlns:a16="http://schemas.microsoft.com/office/drawing/2014/main" id="{0D010FCE-78EA-4E26-A4BA-EE0E8AFBC3F8}"/>
+                <a16:creationId xmlns:a16="http://schemas.microsoft.com/office/drawing/2014/main" id="{9FDEDDE1-D73C-4577-8327-8F7C1DFAB042}"/>
               </a:ext>
             </a:extLst>
           </p:cNvPr>
@@ -10737,7 +10737,7 @@
           <p:cNvPr id="20" name="">
             <a:extLst xmlns:a="http://schemas.openxmlformats.org/drawingml/2006/main">
               <a:ext uri="{FF2B5EF4-FFF2-40B4-BE49-F238E27FC236}">
-                <a16:creationId xmlns:a16="http://schemas.microsoft.com/office/drawing/2014/main" id="{283B14E8-79D5-4A93-A5D9-C96BFB71511D}"/>
+                <a16:creationId xmlns:a16="http://schemas.microsoft.com/office/drawing/2014/main" id="{F8FB751D-2539-4421-A422-F0D0BC59BE95}"/>
               </a:ext>
             </a:extLst>
           </p:cNvPr>
@@ -10828,7 +10828,7 @@
           <p:cNvPr id="21" name="">
             <a:extLst xmlns:a="http://schemas.openxmlformats.org/drawingml/2006/main">
               <a:ext uri="{FF2B5EF4-FFF2-40B4-BE49-F238E27FC236}">
-                <a16:creationId xmlns:a16="http://schemas.microsoft.com/office/drawing/2014/main" id="{87D803AD-DFB3-4C3B-8FFD-0D42079EB5F9}"/>
+                <a16:creationId xmlns:a16="http://schemas.microsoft.com/office/drawing/2014/main" id="{D0EEE63A-B179-4BE0-9F75-72E1953168F9}"/>
               </a:ext>
             </a:extLst>
           </p:cNvPr>
@@ -10862,7 +10862,7 @@
           <p:cNvPr id="22" name="">
             <a:extLst xmlns:a="http://schemas.openxmlformats.org/drawingml/2006/main">
               <a:ext uri="{FF2B5EF4-FFF2-40B4-BE49-F238E27FC236}">
-                <a16:creationId xmlns:a16="http://schemas.microsoft.com/office/drawing/2014/main" id="{FCBF5FD2-6E39-4C45-971D-881750D15896}"/>
+                <a16:creationId xmlns:a16="http://schemas.microsoft.com/office/drawing/2014/main" id="{D08D2B37-DFCF-4900-9F3D-175854834C0A}"/>
               </a:ext>
             </a:extLst>
           </p:cNvPr>
@@ -10930,7 +10930,7 @@
           <p:cNvPr id="23" name="">
             <a:extLst xmlns:a="http://schemas.openxmlformats.org/drawingml/2006/main">
               <a:ext uri="{FF2B5EF4-FFF2-40B4-BE49-F238E27FC236}">
-                <a16:creationId xmlns:a16="http://schemas.microsoft.com/office/drawing/2014/main" id="{D07AE2D2-0CC4-43F9-A47F-3FEA8B3CE5E6}"/>
+                <a16:creationId xmlns:a16="http://schemas.microsoft.com/office/drawing/2014/main" id="{BC23BF08-5CD7-4E51-9C72-E54A154807B2}"/>
               </a:ext>
             </a:extLst>
           </p:cNvPr>
@@ -11021,7 +11021,7 @@
           <p:cNvPr id="24" name="">
             <a:extLst xmlns:a="http://schemas.openxmlformats.org/drawingml/2006/main">
               <a:ext uri="{FF2B5EF4-FFF2-40B4-BE49-F238E27FC236}">
-                <a16:creationId xmlns:a16="http://schemas.microsoft.com/office/drawing/2014/main" id="{526C5CE3-79EB-4D73-B19C-6FF2C3FA69BE}"/>
+                <a16:creationId xmlns:a16="http://schemas.microsoft.com/office/drawing/2014/main" id="{11AF4DDF-A659-43E2-974B-89461094FBBF}"/>
               </a:ext>
             </a:extLst>
           </p:cNvPr>
@@ -11051,7 +11051,7 @@
           <p:cNvPr id="25" name="">
             <a:extLst xmlns:a="http://schemas.openxmlformats.org/drawingml/2006/main">
               <a:ext uri="{FF2B5EF4-FFF2-40B4-BE49-F238E27FC236}">
-                <a16:creationId xmlns:a16="http://schemas.microsoft.com/office/drawing/2014/main" id="{45B30D75-7F7B-4DF4-9AC1-801ED7A5CB54}"/>
+                <a16:creationId xmlns:a16="http://schemas.microsoft.com/office/drawing/2014/main" id="{D88CF9F7-2B2F-460F-9393-F9F0B6144DAD}"/>
               </a:ext>
             </a:extLst>
           </p:cNvPr>
@@ -11081,7 +11081,7 @@
           <p:cNvPr id="26" name="">
             <a:extLst xmlns:a="http://schemas.openxmlformats.org/drawingml/2006/main">
               <a:ext uri="{FF2B5EF4-FFF2-40B4-BE49-F238E27FC236}">
-                <a16:creationId xmlns:a16="http://schemas.microsoft.com/office/drawing/2014/main" id="{55EB9CE5-1A3C-45B5-8861-0554D740C5D0}"/>
+                <a16:creationId xmlns:a16="http://schemas.microsoft.com/office/drawing/2014/main" id="{73A601CD-2862-47B2-90CC-BE33533CA220}"/>
               </a:ext>
             </a:extLst>
           </p:cNvPr>
@@ -11111,7 +11111,7 @@
           <p:cNvPr id="27" name="">
             <a:extLst xmlns:a="http://schemas.openxmlformats.org/drawingml/2006/main">
               <a:ext uri="{FF2B5EF4-FFF2-40B4-BE49-F238E27FC236}">
-                <a16:creationId xmlns:a16="http://schemas.microsoft.com/office/drawing/2014/main" id="{EBF1333C-2CB8-41A0-8D59-90D36CF38F5E}"/>
+                <a16:creationId xmlns:a16="http://schemas.microsoft.com/office/drawing/2014/main" id="{18E6F126-6EEB-4809-BA9D-B66D6BC3D3E8}"/>
               </a:ext>
             </a:extLst>
           </p:cNvPr>
@@ -11141,7 +11141,7 @@
           <p:cNvPr id="28" name="">
             <a:extLst xmlns:a="http://schemas.openxmlformats.org/drawingml/2006/main">
               <a:ext uri="{FF2B5EF4-FFF2-40B4-BE49-F238E27FC236}">
-                <a16:creationId xmlns:a16="http://schemas.microsoft.com/office/drawing/2014/main" id="{B131BF71-A574-4EB3-9C4D-A003CB10FAEA}"/>
+                <a16:creationId xmlns:a16="http://schemas.microsoft.com/office/drawing/2014/main" id="{37653CE4-B004-4063-BD62-C7FD962DFF9A}"/>
               </a:ext>
             </a:extLst>
           </p:cNvPr>
@@ -11207,7 +11207,7 @@
     </p:spTree>
     <p:extLst>
       <p:ext uri="{BB962C8B-B14F-4D97-AF65-F5344CB8AC3E}">
-        <p14:creationId xmlns:p14="http://schemas.microsoft.com/office/powerpoint/2010/main" val="607048661"/>
+        <p14:creationId xmlns:p14="http://schemas.microsoft.com/office/powerpoint/2010/main" val="117879004"/>
       </p:ext>
     </p:extLst>
   </p:cSld>
@@ -11238,7 +11238,7 @@
           <p:cNvPr id="22" name="">
             <a:extLst xmlns:a="http://schemas.openxmlformats.org/drawingml/2006/main">
               <a:ext uri="{FF2B5EF4-FFF2-40B4-BE49-F238E27FC236}">
-                <a16:creationId xmlns:a16="http://schemas.microsoft.com/office/drawing/2014/main" id="{BA4E1CEE-C4C6-4EF2-AD05-5CB297B2BA6D}"/>
+                <a16:creationId xmlns:a16="http://schemas.microsoft.com/office/drawing/2014/main" id="{A54C5DDA-D2C5-480F-A203-F0C84E5AD00B}"/>
               </a:ext>
             </a:extLst>
           </p:cNvPr>
@@ -11306,7 +11306,7 @@
           <p:cNvPr id="2" name="">
             <a:extLst xmlns:a="http://schemas.openxmlformats.org/drawingml/2006/main">
               <a:ext uri="{FF2B5EF4-FFF2-40B4-BE49-F238E27FC236}">
-                <a16:creationId xmlns:a16="http://schemas.microsoft.com/office/drawing/2014/main" id="{D757A24C-662F-46EE-81A8-90D6249D11ED}"/>
+                <a16:creationId xmlns:a16="http://schemas.microsoft.com/office/drawing/2014/main" id="{DF3D90E9-2AA5-4A9E-A749-8C7C92E007E0}"/>
               </a:ext>
             </a:extLst>
           </p:cNvPr>
@@ -11374,7 +11374,7 @@
           <p:cNvPr id="3" name="">
             <a:extLst xmlns:a="http://schemas.openxmlformats.org/drawingml/2006/main">
               <a:ext uri="{FF2B5EF4-FFF2-40B4-BE49-F238E27FC236}">
-                <a16:creationId xmlns:a16="http://schemas.microsoft.com/office/drawing/2014/main" id="{30E93DCA-F173-4352-A188-4FEAEB3AF105}"/>
+                <a16:creationId xmlns:a16="http://schemas.microsoft.com/office/drawing/2014/main" id="{DD704BC7-33DC-46FF-A1BC-17BBE7B54F99}"/>
               </a:ext>
             </a:extLst>
           </p:cNvPr>
@@ -11404,7 +11404,7 @@
           <p:cNvPr id="4" name="">
             <a:extLst xmlns:a="http://schemas.openxmlformats.org/drawingml/2006/main">
               <a:ext uri="{FF2B5EF4-FFF2-40B4-BE49-F238E27FC236}">
-                <a16:creationId xmlns:a16="http://schemas.microsoft.com/office/drawing/2014/main" id="{254D1F92-276E-4D9F-B01B-B1DEE8657DEB}"/>
+                <a16:creationId xmlns:a16="http://schemas.microsoft.com/office/drawing/2014/main" id="{637C8BEA-EF2E-4067-B640-815E1E0DA4D3}"/>
               </a:ext>
             </a:extLst>
           </p:cNvPr>
@@ -11472,7 +11472,7 @@
           <p:cNvPr id="5" name="">
             <a:extLst xmlns:a="http://schemas.openxmlformats.org/drawingml/2006/main">
               <a:ext uri="{FF2B5EF4-FFF2-40B4-BE49-F238E27FC236}">
-                <a16:creationId xmlns:a16="http://schemas.microsoft.com/office/drawing/2014/main" id="{1D9F34BD-2F11-40EB-89B2-03E0635653D7}"/>
+                <a16:creationId xmlns:a16="http://schemas.microsoft.com/office/drawing/2014/main" id="{92697335-2F5C-4F6E-9D83-D689AFDB301B}"/>
               </a:ext>
             </a:extLst>
           </p:cNvPr>
@@ -11540,7 +11540,7 @@
           <p:cNvPr id="6" name="">
             <a:extLst xmlns:a="http://schemas.openxmlformats.org/drawingml/2006/main">
               <a:ext uri="{FF2B5EF4-FFF2-40B4-BE49-F238E27FC236}">
-                <a16:creationId xmlns:a16="http://schemas.microsoft.com/office/drawing/2014/main" id="{3A68C98F-4DC5-4386-9FB9-EF9D0182C534}"/>
+                <a16:creationId xmlns:a16="http://schemas.microsoft.com/office/drawing/2014/main" id="{AEFE1FB1-4CFE-43A7-AC22-5E66A193F942}"/>
               </a:ext>
             </a:extLst>
           </p:cNvPr>
@@ -11574,7 +11574,7 @@
           <p:cNvPr id="7" name="">
             <a:extLst xmlns:a="http://schemas.openxmlformats.org/drawingml/2006/main">
               <a:ext uri="{FF2B5EF4-FFF2-40B4-BE49-F238E27FC236}">
-                <a16:creationId xmlns:a16="http://schemas.microsoft.com/office/drawing/2014/main" id="{8A91DDA2-CB0B-41E4-8964-3E17BA3981AE}"/>
+                <a16:creationId xmlns:a16="http://schemas.microsoft.com/office/drawing/2014/main" id="{2A08EFE4-4CE6-44F9-93F1-6397271E936C}"/>
               </a:ext>
             </a:extLst>
           </p:cNvPr>
@@ -11642,7 +11642,7 @@
           <p:cNvPr id="8" name="">
             <a:extLst xmlns:a="http://schemas.openxmlformats.org/drawingml/2006/main">
               <a:ext uri="{FF2B5EF4-FFF2-40B4-BE49-F238E27FC236}">
-                <a16:creationId xmlns:a16="http://schemas.microsoft.com/office/drawing/2014/main" id="{3D076379-B42D-49B3-8C93-D8DEDE5F21DD}"/>
+                <a16:creationId xmlns:a16="http://schemas.microsoft.com/office/drawing/2014/main" id="{BFAEA2E0-6167-4AE2-826C-98EEE46392F7}"/>
               </a:ext>
             </a:extLst>
           </p:cNvPr>
@@ -11710,7 +11710,7 @@
           <p:cNvPr id="9" name="">
             <a:extLst xmlns:a="http://schemas.openxmlformats.org/drawingml/2006/main">
               <a:ext uri="{FF2B5EF4-FFF2-40B4-BE49-F238E27FC236}">
-                <a16:creationId xmlns:a16="http://schemas.microsoft.com/office/drawing/2014/main" id="{0EFFF2B8-1381-4442-9EED-A819A792AC06}"/>
+                <a16:creationId xmlns:a16="http://schemas.microsoft.com/office/drawing/2014/main" id="{DCEA0F9C-FD1C-441D-96D1-1F3FCEE488E2}"/>
               </a:ext>
             </a:extLst>
           </p:cNvPr>
@@ -11744,7 +11744,7 @@
           <p:cNvPr id="10" name="">
             <a:extLst xmlns:a="http://schemas.openxmlformats.org/drawingml/2006/main">
               <a:ext uri="{FF2B5EF4-FFF2-40B4-BE49-F238E27FC236}">
-                <a16:creationId xmlns:a16="http://schemas.microsoft.com/office/drawing/2014/main" id="{8D9A2A11-FEA4-4A03-BCEB-A7BEC7247FDA}"/>
+                <a16:creationId xmlns:a16="http://schemas.microsoft.com/office/drawing/2014/main" id="{B7596F96-5C4E-4503-83B1-A9B5D1A00607}"/>
               </a:ext>
             </a:extLst>
           </p:cNvPr>
@@ -11812,7 +11812,7 @@
           <p:cNvPr id="11" name="">
             <a:extLst xmlns:a="http://schemas.openxmlformats.org/drawingml/2006/main">
               <a:ext uri="{FF2B5EF4-FFF2-40B4-BE49-F238E27FC236}">
-                <a16:creationId xmlns:a16="http://schemas.microsoft.com/office/drawing/2014/main" id="{8359CE76-A70E-426B-B3CC-8070D81B8F07}"/>
+                <a16:creationId xmlns:a16="http://schemas.microsoft.com/office/drawing/2014/main" id="{9A1D57EC-057F-4E0C-9F68-C43494092E1E}"/>
               </a:ext>
             </a:extLst>
           </p:cNvPr>
@@ -11880,7 +11880,7 @@
           <p:cNvPr id="12" name="">
             <a:extLst xmlns:a="http://schemas.openxmlformats.org/drawingml/2006/main">
               <a:ext uri="{FF2B5EF4-FFF2-40B4-BE49-F238E27FC236}">
-                <a16:creationId xmlns:a16="http://schemas.microsoft.com/office/drawing/2014/main" id="{A248D611-1DFC-4DDF-9D73-1002BC49E22F}"/>
+                <a16:creationId xmlns:a16="http://schemas.microsoft.com/office/drawing/2014/main" id="{06526E12-2CB0-4D96-A7DC-1778CD6C0765}"/>
               </a:ext>
             </a:extLst>
           </p:cNvPr>
@@ -11914,7 +11914,7 @@
           <p:cNvPr id="13" name="">
             <a:extLst xmlns:a="http://schemas.openxmlformats.org/drawingml/2006/main">
               <a:ext uri="{FF2B5EF4-FFF2-40B4-BE49-F238E27FC236}">
-                <a16:creationId xmlns:a16="http://schemas.microsoft.com/office/drawing/2014/main" id="{46563DAD-715A-48C0-BB7C-4E58D4B9CDB6}"/>
+                <a16:creationId xmlns:a16="http://schemas.microsoft.com/office/drawing/2014/main" id="{B984AEAD-3F24-4867-8945-E9F256320939}"/>
               </a:ext>
             </a:extLst>
           </p:cNvPr>
@@ -11982,7 +11982,7 @@
           <p:cNvPr id="14" name="">
             <a:extLst xmlns:a="http://schemas.openxmlformats.org/drawingml/2006/main">
               <a:ext uri="{FF2B5EF4-FFF2-40B4-BE49-F238E27FC236}">
-                <a16:creationId xmlns:a16="http://schemas.microsoft.com/office/drawing/2014/main" id="{B8A34497-67CE-445C-B7F5-CAD6043AD094}"/>
+                <a16:creationId xmlns:a16="http://schemas.microsoft.com/office/drawing/2014/main" id="{EF2BB3D9-411B-48B1-B4C3-1225B51BA37B}"/>
               </a:ext>
             </a:extLst>
           </p:cNvPr>
@@ -12050,7 +12050,7 @@
           <p:cNvPr id="15" name="">
             <a:extLst xmlns:a="http://schemas.openxmlformats.org/drawingml/2006/main">
               <a:ext uri="{FF2B5EF4-FFF2-40B4-BE49-F238E27FC236}">
-                <a16:creationId xmlns:a16="http://schemas.microsoft.com/office/drawing/2014/main" id="{FBFB0A81-9ED0-4509-A8DD-3D5B47924F29}"/>
+                <a16:creationId xmlns:a16="http://schemas.microsoft.com/office/drawing/2014/main" id="{8A45C406-A77C-4391-A330-7B0E6A6756DD}"/>
               </a:ext>
             </a:extLst>
           </p:cNvPr>
@@ -12080,7 +12080,7 @@
           <p:cNvPr id="16" name="">
             <a:extLst xmlns:a="http://schemas.openxmlformats.org/drawingml/2006/main">
               <a:ext uri="{FF2B5EF4-FFF2-40B4-BE49-F238E27FC236}">
-                <a16:creationId xmlns:a16="http://schemas.microsoft.com/office/drawing/2014/main" id="{5D937613-FD6B-4EC7-80F4-880D69C7DADA}"/>
+                <a16:creationId xmlns:a16="http://schemas.microsoft.com/office/drawing/2014/main" id="{EA79A5D2-317B-4572-ACFF-847130224D53}"/>
               </a:ext>
             </a:extLst>
           </p:cNvPr>
@@ -12110,7 +12110,7 @@
           <p:cNvPr id="17" name="">
             <a:extLst xmlns:a="http://schemas.openxmlformats.org/drawingml/2006/main">
               <a:ext uri="{FF2B5EF4-FFF2-40B4-BE49-F238E27FC236}">
-                <a16:creationId xmlns:a16="http://schemas.microsoft.com/office/drawing/2014/main" id="{DCA66D9B-6AEE-477D-88A8-670100C15C3B}"/>
+                <a16:creationId xmlns:a16="http://schemas.microsoft.com/office/drawing/2014/main" id="{5C7D39C0-5970-48DE-AD7C-8FC87DD3D3F8}"/>
               </a:ext>
             </a:extLst>
           </p:cNvPr>
@@ -12140,7 +12140,7 @@
           <p:cNvPr id="18" name="">
             <a:extLst xmlns:a="http://schemas.openxmlformats.org/drawingml/2006/main">
               <a:ext uri="{FF2B5EF4-FFF2-40B4-BE49-F238E27FC236}">
-                <a16:creationId xmlns:a16="http://schemas.microsoft.com/office/drawing/2014/main" id="{A24C8760-8D90-4E6A-9A1A-11A58A4EEA8F}"/>
+                <a16:creationId xmlns:a16="http://schemas.microsoft.com/office/drawing/2014/main" id="{B860B6FD-5842-4A8F-A45D-4C2DF620DCFE}"/>
               </a:ext>
             </a:extLst>
           </p:cNvPr>
@@ -12208,7 +12208,7 @@
           <p:cNvPr id="19" name="">
             <a:extLst xmlns:a="http://schemas.openxmlformats.org/drawingml/2006/main">
               <a:ext uri="{FF2B5EF4-FFF2-40B4-BE49-F238E27FC236}">
-                <a16:creationId xmlns:a16="http://schemas.microsoft.com/office/drawing/2014/main" id="{B1E8682E-0E1F-4B01-BCD5-811469E523A7}"/>
+                <a16:creationId xmlns:a16="http://schemas.microsoft.com/office/drawing/2014/main" id="{FF6DF7A1-FDDF-4A77-98B4-B4C97C4B02D3}"/>
               </a:ext>
             </a:extLst>
           </p:cNvPr>
@@ -12276,7 +12276,7 @@
           <p:cNvPr id="20" name="">
             <a:extLst xmlns:a="http://schemas.openxmlformats.org/drawingml/2006/main">
               <a:ext uri="{FF2B5EF4-FFF2-40B4-BE49-F238E27FC236}">
-                <a16:creationId xmlns:a16="http://schemas.microsoft.com/office/drawing/2014/main" id="{A9663F7D-7062-45E3-983F-D65C4DAD7FF2}"/>
+                <a16:creationId xmlns:a16="http://schemas.microsoft.com/office/drawing/2014/main" id="{412F8DB4-8770-42FC-BC0C-0BFD4403FDA3}"/>
               </a:ext>
             </a:extLst>
           </p:cNvPr>
@@ -12344,7 +12344,7 @@
           <p:cNvPr id="21" name="">
             <a:extLst xmlns:a="http://schemas.openxmlformats.org/drawingml/2006/main">
               <a:ext uri="{FF2B5EF4-FFF2-40B4-BE49-F238E27FC236}">
-                <a16:creationId xmlns:a16="http://schemas.microsoft.com/office/drawing/2014/main" id="{69C633A9-5EA8-499C-943E-B961027FBA04}"/>
+                <a16:creationId xmlns:a16="http://schemas.microsoft.com/office/drawing/2014/main" id="{3F76CD17-42AC-45AC-8B4C-EC0F6500866E}"/>
               </a:ext>
             </a:extLst>
           </p:cNvPr>
@@ -12410,7 +12410,7 @@
     </p:spTree>
     <p:extLst>
       <p:ext uri="{BB962C8B-B14F-4D97-AF65-F5344CB8AC3E}">
-        <p14:creationId xmlns:p14="http://schemas.microsoft.com/office/powerpoint/2010/main" val="1237773043"/>
+        <p14:creationId xmlns:p14="http://schemas.microsoft.com/office/powerpoint/2010/main" val="280587205"/>
       </p:ext>
     </p:extLst>
   </p:cSld>
@@ -12441,7 +12441,7 @@
           <p:cNvPr id="30" name="">
             <a:extLst xmlns:a="http://schemas.openxmlformats.org/drawingml/2006/main">
               <a:ext uri="{FF2B5EF4-FFF2-40B4-BE49-F238E27FC236}">
-                <a16:creationId xmlns:a16="http://schemas.microsoft.com/office/drawing/2014/main" id="{F61DEEE0-865A-4627-8EBF-D467B406BB1C}"/>
+                <a16:creationId xmlns:a16="http://schemas.microsoft.com/office/drawing/2014/main" id="{803EBAC1-CE7F-4216-9634-118B589D9AC4}"/>
               </a:ext>
             </a:extLst>
           </p:cNvPr>
@@ -12509,7 +12509,7 @@
           <p:cNvPr id="2" name="">
             <a:extLst xmlns:a="http://schemas.openxmlformats.org/drawingml/2006/main">
               <a:ext uri="{FF2B5EF4-FFF2-40B4-BE49-F238E27FC236}">
-                <a16:creationId xmlns:a16="http://schemas.microsoft.com/office/drawing/2014/main" id="{3E3BD72B-7660-469E-9E1B-C423FA6D8B93}"/>
+                <a16:creationId xmlns:a16="http://schemas.microsoft.com/office/drawing/2014/main" id="{F3969F70-B366-483A-9A54-82882966E686}"/>
               </a:ext>
             </a:extLst>
           </p:cNvPr>
@@ -12577,7 +12577,7 @@
           <p:cNvPr id="3" name="">
             <a:extLst xmlns:a="http://schemas.openxmlformats.org/drawingml/2006/main">
               <a:ext uri="{FF2B5EF4-FFF2-40B4-BE49-F238E27FC236}">
-                <a16:creationId xmlns:a16="http://schemas.microsoft.com/office/drawing/2014/main" id="{DC768F86-E2C1-4142-B707-9E2481F7AC23}"/>
+                <a16:creationId xmlns:a16="http://schemas.microsoft.com/office/drawing/2014/main" id="{C4B88D3C-D5DF-42BC-A214-FC04FEF440B1}"/>
               </a:ext>
             </a:extLst>
           </p:cNvPr>
@@ -12607,7 +12607,7 @@
           <p:cNvPr id="4" name="">
             <a:extLst xmlns:a="http://schemas.openxmlformats.org/drawingml/2006/main">
               <a:ext uri="{FF2B5EF4-FFF2-40B4-BE49-F238E27FC236}">
-                <a16:creationId xmlns:a16="http://schemas.microsoft.com/office/drawing/2014/main" id="{8285755D-9828-494F-A284-B3B2FD14CAD6}"/>
+                <a16:creationId xmlns:a16="http://schemas.microsoft.com/office/drawing/2014/main" id="{7EDCF2F9-00B1-4E23-9493-DF6B25D1B489}"/>
               </a:ext>
             </a:extLst>
           </p:cNvPr>
@@ -12675,7 +12675,7 @@
           <p:cNvPr id="5" name="">
             <a:extLst xmlns:a="http://schemas.openxmlformats.org/drawingml/2006/main">
               <a:ext uri="{FF2B5EF4-FFF2-40B4-BE49-F238E27FC236}">
-                <a16:creationId xmlns:a16="http://schemas.microsoft.com/office/drawing/2014/main" id="{113F21DC-915E-4EC6-87FC-20AAD0D33F03}"/>
+                <a16:creationId xmlns:a16="http://schemas.microsoft.com/office/drawing/2014/main" id="{0E7ED77B-D38B-49B3-89C4-4C3978369715}"/>
               </a:ext>
             </a:extLst>
           </p:cNvPr>
@@ -12743,7 +12743,7 @@
           <p:cNvPr id="6" name="">
             <a:extLst xmlns:a="http://schemas.openxmlformats.org/drawingml/2006/main">
               <a:ext uri="{FF2B5EF4-FFF2-40B4-BE49-F238E27FC236}">
-                <a16:creationId xmlns:a16="http://schemas.microsoft.com/office/drawing/2014/main" id="{78336F35-F80F-4F9F-A56B-B5F839FC5492}"/>
+                <a16:creationId xmlns:a16="http://schemas.microsoft.com/office/drawing/2014/main" id="{8C136E31-6734-4E9E-A593-DB354534601D}"/>
               </a:ext>
             </a:extLst>
           </p:cNvPr>
@@ -12777,7 +12777,7 @@
           <p:cNvPr id="7" name="">
             <a:extLst xmlns:a="http://schemas.openxmlformats.org/drawingml/2006/main">
               <a:ext uri="{FF2B5EF4-FFF2-40B4-BE49-F238E27FC236}">
-                <a16:creationId xmlns:a16="http://schemas.microsoft.com/office/drawing/2014/main" id="{3D83A7F0-893B-4FB2-8425-2C1EBD39EC35}"/>
+                <a16:creationId xmlns:a16="http://schemas.microsoft.com/office/drawing/2014/main" id="{86AF2266-ABBF-4A4F-97D0-F1F6B055DC27}"/>
               </a:ext>
             </a:extLst>
           </p:cNvPr>
@@ -12845,7 +12845,7 @@
           <p:cNvPr id="8" name="">
             <a:extLst xmlns:a="http://schemas.openxmlformats.org/drawingml/2006/main">
               <a:ext uri="{FF2B5EF4-FFF2-40B4-BE49-F238E27FC236}">
-                <a16:creationId xmlns:a16="http://schemas.microsoft.com/office/drawing/2014/main" id="{22AE2278-9853-4FA6-A963-5248F3D27C5B}"/>
+                <a16:creationId xmlns:a16="http://schemas.microsoft.com/office/drawing/2014/main" id="{56278C31-9155-4F6C-9B71-37E0FE020072}"/>
               </a:ext>
             </a:extLst>
           </p:cNvPr>
@@ -12936,7 +12936,7 @@
           <p:cNvPr id="9" name="">
             <a:extLst xmlns:a="http://schemas.openxmlformats.org/drawingml/2006/main">
               <a:ext uri="{FF2B5EF4-FFF2-40B4-BE49-F238E27FC236}">
-                <a16:creationId xmlns:a16="http://schemas.microsoft.com/office/drawing/2014/main" id="{02ECCAB3-5787-47FA-A3F0-566A9FA53513}"/>
+                <a16:creationId xmlns:a16="http://schemas.microsoft.com/office/drawing/2014/main" id="{FB5165DF-F99F-4A27-BAFA-7E49353FE603}"/>
               </a:ext>
             </a:extLst>
           </p:cNvPr>
@@ -12966,7 +12966,7 @@
           <p:cNvPr id="10" name="">
             <a:extLst xmlns:a="http://schemas.openxmlformats.org/drawingml/2006/main">
               <a:ext uri="{FF2B5EF4-FFF2-40B4-BE49-F238E27FC236}">
-                <a16:creationId xmlns:a16="http://schemas.microsoft.com/office/drawing/2014/main" id="{DB4DB74B-8398-47A3-9602-3131D749CBBC}"/>
+                <a16:creationId xmlns:a16="http://schemas.microsoft.com/office/drawing/2014/main" id="{4ADAD660-ED48-49C8-9FC9-49A0D820377B}"/>
               </a:ext>
             </a:extLst>
           </p:cNvPr>
@@ -13000,7 +13000,7 @@
           <p:cNvPr id="11" name="">
             <a:extLst xmlns:a="http://schemas.openxmlformats.org/drawingml/2006/main">
               <a:ext uri="{FF2B5EF4-FFF2-40B4-BE49-F238E27FC236}">
-                <a16:creationId xmlns:a16="http://schemas.microsoft.com/office/drawing/2014/main" id="{85C577D1-A549-4745-A99E-824233641316}"/>
+                <a16:creationId xmlns:a16="http://schemas.microsoft.com/office/drawing/2014/main" id="{E4F578ED-F4FD-464A-B2E6-0031F0392775}"/>
               </a:ext>
             </a:extLst>
           </p:cNvPr>
@@ -13068,7 +13068,7 @@
           <p:cNvPr id="12" name="">
             <a:extLst xmlns:a="http://schemas.openxmlformats.org/drawingml/2006/main">
               <a:ext uri="{FF2B5EF4-FFF2-40B4-BE49-F238E27FC236}">
-                <a16:creationId xmlns:a16="http://schemas.microsoft.com/office/drawing/2014/main" id="{FB6E0451-185C-41AB-BFAF-1855C7ED391A}"/>
+                <a16:creationId xmlns:a16="http://schemas.microsoft.com/office/drawing/2014/main" id="{6C777F33-2F3A-4326-A83E-B26514769678}"/>
               </a:ext>
             </a:extLst>
           </p:cNvPr>
@@ -13159,7 +13159,7 @@
           <p:cNvPr id="13" name="">
             <a:extLst xmlns:a="http://schemas.openxmlformats.org/drawingml/2006/main">
               <a:ext uri="{FF2B5EF4-FFF2-40B4-BE49-F238E27FC236}">
-                <a16:creationId xmlns:a16="http://schemas.microsoft.com/office/drawing/2014/main" id="{42830DF7-881E-4EE0-A5B3-54F45358C2A4}"/>
+                <a16:creationId xmlns:a16="http://schemas.microsoft.com/office/drawing/2014/main" id="{DE273DB1-2FA5-4E34-91E5-7EDAFD98E504}"/>
               </a:ext>
             </a:extLst>
           </p:cNvPr>
@@ -13189,7 +13189,7 @@
           <p:cNvPr id="14" name="">
             <a:extLst xmlns:a="http://schemas.openxmlformats.org/drawingml/2006/main">
               <a:ext uri="{FF2B5EF4-FFF2-40B4-BE49-F238E27FC236}">
-                <a16:creationId xmlns:a16="http://schemas.microsoft.com/office/drawing/2014/main" id="{249BFBD6-8D22-4B58-B3CC-32D26BFF1512}"/>
+                <a16:creationId xmlns:a16="http://schemas.microsoft.com/office/drawing/2014/main" id="{B8CB325B-34AF-4CA9-9A08-CF00CB29EAE5}"/>
               </a:ext>
             </a:extLst>
           </p:cNvPr>
@@ -13223,7 +13223,7 @@
           <p:cNvPr id="15" name="">
             <a:extLst xmlns:a="http://schemas.openxmlformats.org/drawingml/2006/main">
               <a:ext uri="{FF2B5EF4-FFF2-40B4-BE49-F238E27FC236}">
-                <a16:creationId xmlns:a16="http://schemas.microsoft.com/office/drawing/2014/main" id="{6C8ABD60-56FF-498E-BCAA-4FF0F03212CB}"/>
+                <a16:creationId xmlns:a16="http://schemas.microsoft.com/office/drawing/2014/main" id="{A27B30CF-854C-4050-948E-0AF03189F6A6}"/>
               </a:ext>
             </a:extLst>
           </p:cNvPr>
@@ -13291,7 +13291,7 @@
           <p:cNvPr id="16" name="">
             <a:extLst xmlns:a="http://schemas.openxmlformats.org/drawingml/2006/main">
               <a:ext uri="{FF2B5EF4-FFF2-40B4-BE49-F238E27FC236}">
-                <a16:creationId xmlns:a16="http://schemas.microsoft.com/office/drawing/2014/main" id="{0D6719C7-7A7B-4EB9-BFE1-4AEFEB8877A0}"/>
+                <a16:creationId xmlns:a16="http://schemas.microsoft.com/office/drawing/2014/main" id="{4154C07E-88A3-47DC-8955-04F37C1C6103}"/>
               </a:ext>
             </a:extLst>
           </p:cNvPr>
@@ -13382,7 +13382,7 @@
           <p:cNvPr id="17" name="">
             <a:extLst xmlns:a="http://schemas.openxmlformats.org/drawingml/2006/main">
               <a:ext uri="{FF2B5EF4-FFF2-40B4-BE49-F238E27FC236}">
-                <a16:creationId xmlns:a16="http://schemas.microsoft.com/office/drawing/2014/main" id="{35326F66-50E0-48FE-B950-6481B06921F3}"/>
+                <a16:creationId xmlns:a16="http://schemas.microsoft.com/office/drawing/2014/main" id="{A8B83E61-A611-437E-921C-BB4CD7485DE1}"/>
               </a:ext>
             </a:extLst>
           </p:cNvPr>
@@ -13412,7 +13412,7 @@
           <p:cNvPr id="18" name="">
             <a:extLst xmlns:a="http://schemas.openxmlformats.org/drawingml/2006/main">
               <a:ext uri="{FF2B5EF4-FFF2-40B4-BE49-F238E27FC236}">
-                <a16:creationId xmlns:a16="http://schemas.microsoft.com/office/drawing/2014/main" id="{89C460C1-B100-486B-8BAB-26CF838DC907}"/>
+                <a16:creationId xmlns:a16="http://schemas.microsoft.com/office/drawing/2014/main" id="{BCF598D8-542D-4977-B49E-C4D5861BFEB4}"/>
               </a:ext>
             </a:extLst>
           </p:cNvPr>
@@ -13446,7 +13446,7 @@
           <p:cNvPr id="19" name="">
             <a:extLst xmlns:a="http://schemas.openxmlformats.org/drawingml/2006/main">
               <a:ext uri="{FF2B5EF4-FFF2-40B4-BE49-F238E27FC236}">
-                <a16:creationId xmlns:a16="http://schemas.microsoft.com/office/drawing/2014/main" id="{5B09C715-CA65-46EF-8F4B-75F19114CD80}"/>
+                <a16:creationId xmlns:a16="http://schemas.microsoft.com/office/drawing/2014/main" id="{9D0377D5-1917-46A2-B002-F0FCF704080D}"/>
               </a:ext>
             </a:extLst>
           </p:cNvPr>
@@ -13514,7 +13514,7 @@
           <p:cNvPr id="20" name="">
             <a:extLst xmlns:a="http://schemas.openxmlformats.org/drawingml/2006/main">
               <a:ext uri="{FF2B5EF4-FFF2-40B4-BE49-F238E27FC236}">
-                <a16:creationId xmlns:a16="http://schemas.microsoft.com/office/drawing/2014/main" id="{058C5BF0-7BD4-4E38-BEE6-FFE38E0F4E1F}"/>
+                <a16:creationId xmlns:a16="http://schemas.microsoft.com/office/drawing/2014/main" id="{28C95F8F-E563-43D1-B2EF-D17174E4463A}"/>
               </a:ext>
             </a:extLst>
           </p:cNvPr>
@@ -13605,7 +13605,7 @@
           <p:cNvPr id="21" name="">
             <a:extLst xmlns:a="http://schemas.openxmlformats.org/drawingml/2006/main">
               <a:ext uri="{FF2B5EF4-FFF2-40B4-BE49-F238E27FC236}">
-                <a16:creationId xmlns:a16="http://schemas.microsoft.com/office/drawing/2014/main" id="{363DACAA-90FB-476F-97AF-4D3C554A3B2B}"/>
+                <a16:creationId xmlns:a16="http://schemas.microsoft.com/office/drawing/2014/main" id="{5BA58843-E2BA-4CE5-B2FB-EA3E0686F066}"/>
               </a:ext>
             </a:extLst>
           </p:cNvPr>
@@ -13635,7 +13635,7 @@
           <p:cNvPr id="22" name="">
             <a:extLst xmlns:a="http://schemas.openxmlformats.org/drawingml/2006/main">
               <a:ext uri="{FF2B5EF4-FFF2-40B4-BE49-F238E27FC236}">
-                <a16:creationId xmlns:a16="http://schemas.microsoft.com/office/drawing/2014/main" id="{0A6F2B51-136B-4460-9112-38C0C9DD1F33}"/>
+                <a16:creationId xmlns:a16="http://schemas.microsoft.com/office/drawing/2014/main" id="{51F252DE-684D-43F1-8893-4EE2477D67AB}"/>
               </a:ext>
             </a:extLst>
           </p:cNvPr>
@@ -13669,7 +13669,7 @@
           <p:cNvPr id="23" name="">
             <a:extLst xmlns:a="http://schemas.openxmlformats.org/drawingml/2006/main">
               <a:ext uri="{FF2B5EF4-FFF2-40B4-BE49-F238E27FC236}">
-                <a16:creationId xmlns:a16="http://schemas.microsoft.com/office/drawing/2014/main" id="{08FFACB5-BC06-42BC-A9DB-292B9E61A3B5}"/>
+                <a16:creationId xmlns:a16="http://schemas.microsoft.com/office/drawing/2014/main" id="{823A2BB8-F943-4F00-B8B1-F10DBFD9D5D7}"/>
               </a:ext>
             </a:extLst>
           </p:cNvPr>
@@ -13737,7 +13737,7 @@
           <p:cNvPr id="24" name="">
             <a:extLst xmlns:a="http://schemas.openxmlformats.org/drawingml/2006/main">
               <a:ext uri="{FF2B5EF4-FFF2-40B4-BE49-F238E27FC236}">
-                <a16:creationId xmlns:a16="http://schemas.microsoft.com/office/drawing/2014/main" id="{452C9599-65D2-4711-AEA4-63A99FB53129}"/>
+                <a16:creationId xmlns:a16="http://schemas.microsoft.com/office/drawing/2014/main" id="{30B4D018-2F78-4120-8700-E70CF0C031A6}"/>
               </a:ext>
             </a:extLst>
           </p:cNvPr>
@@ -13828,7 +13828,7 @@
           <p:cNvPr id="25" name="">
             <a:extLst xmlns:a="http://schemas.openxmlformats.org/drawingml/2006/main">
               <a:ext uri="{FF2B5EF4-FFF2-40B4-BE49-F238E27FC236}">
-                <a16:creationId xmlns:a16="http://schemas.microsoft.com/office/drawing/2014/main" id="{9A16618B-F4D6-462F-B97D-A13A1A74769D}"/>
+                <a16:creationId xmlns:a16="http://schemas.microsoft.com/office/drawing/2014/main" id="{210D9784-E6C7-4C80-BDBD-D0B476F86BA5}"/>
               </a:ext>
             </a:extLst>
           </p:cNvPr>
@@ -13896,7 +13896,7 @@
           <p:cNvPr id="26" name="">
             <a:extLst xmlns:a="http://schemas.openxmlformats.org/drawingml/2006/main">
               <a:ext uri="{FF2B5EF4-FFF2-40B4-BE49-F238E27FC236}">
-                <a16:creationId xmlns:a16="http://schemas.microsoft.com/office/drawing/2014/main" id="{216ACFA4-DC7B-48F6-8A5E-AD59D042B967}"/>
+                <a16:creationId xmlns:a16="http://schemas.microsoft.com/office/drawing/2014/main" id="{8910DC59-F574-4A8B-BD8C-8DCEBE97E102}"/>
               </a:ext>
             </a:extLst>
           </p:cNvPr>
@@ -13964,7 +13964,7 @@
           <p:cNvPr id="27" name="">
             <a:extLst xmlns:a="http://schemas.openxmlformats.org/drawingml/2006/main">
               <a:ext uri="{FF2B5EF4-FFF2-40B4-BE49-F238E27FC236}">
-                <a16:creationId xmlns:a16="http://schemas.microsoft.com/office/drawing/2014/main" id="{49493276-F2E5-4CF8-908F-3ABD3314D4BE}"/>
+                <a16:creationId xmlns:a16="http://schemas.microsoft.com/office/drawing/2014/main" id="{CF7A1C68-67DF-4F86-993B-747098CBA73D}"/>
               </a:ext>
             </a:extLst>
           </p:cNvPr>
@@ -14032,7 +14032,7 @@
           <p:cNvPr id="28" name="">
             <a:extLst xmlns:a="http://schemas.openxmlformats.org/drawingml/2006/main">
               <a:ext uri="{FF2B5EF4-FFF2-40B4-BE49-F238E27FC236}">
-                <a16:creationId xmlns:a16="http://schemas.microsoft.com/office/drawing/2014/main" id="{E2145640-F378-41D3-8429-512004B39BD8}"/>
+                <a16:creationId xmlns:a16="http://schemas.microsoft.com/office/drawing/2014/main" id="{3CB24F91-5238-428F-AFB6-355A45EACF33}"/>
               </a:ext>
             </a:extLst>
           </p:cNvPr>
@@ -14100,7 +14100,7 @@
           <p:cNvPr id="29" name="">
             <a:extLst xmlns:a="http://schemas.openxmlformats.org/drawingml/2006/main">
               <a:ext uri="{FF2B5EF4-FFF2-40B4-BE49-F238E27FC236}">
-                <a16:creationId xmlns:a16="http://schemas.microsoft.com/office/drawing/2014/main" id="{1851A072-A6BE-4129-8954-B7BA58503889}"/>
+                <a16:creationId xmlns:a16="http://schemas.microsoft.com/office/drawing/2014/main" id="{B76C5216-B22F-48C4-80E1-12B8ECBBCFE9}"/>
               </a:ext>
             </a:extLst>
           </p:cNvPr>
@@ -14166,7 +14166,7 @@
     </p:spTree>
     <p:extLst>
       <p:ext uri="{BB962C8B-B14F-4D97-AF65-F5344CB8AC3E}">
-        <p14:creationId xmlns:p14="http://schemas.microsoft.com/office/powerpoint/2010/main" val="1976128303"/>
+        <p14:creationId xmlns:p14="http://schemas.microsoft.com/office/powerpoint/2010/main" val="403038239"/>
       </p:ext>
     </p:extLst>
   </p:cSld>
@@ -14194,10 +14194,10 @@
       </p:grpSpPr>
       <p:sp>
         <p:nvSpPr>
-          <p:cNvPr id="13" name="">
-            <a:extLst xmlns:a="http://schemas.openxmlformats.org/drawingml/2006/main">
-              <a:ext uri="{FF2B5EF4-FFF2-40B4-BE49-F238E27FC236}">
-                <a16:creationId xmlns:a16="http://schemas.microsoft.com/office/drawing/2014/main" id="{3AA9FA22-CFBA-4606-90F3-C0CF4611A792}"/>
+          <p:cNvPr id="14" name="">
+            <a:extLst xmlns:a="http://schemas.openxmlformats.org/drawingml/2006/main">
+              <a:ext uri="{FF2B5EF4-FFF2-40B4-BE49-F238E27FC236}">
+                <a16:creationId xmlns:a16="http://schemas.microsoft.com/office/drawing/2014/main" id="{A66255BE-0707-47E3-9A08-CF20B422BE7C}"/>
               </a:ext>
             </a:extLst>
           </p:cNvPr>
@@ -14265,7 +14265,7 @@
           <p:cNvPr id="2" name="">
             <a:extLst xmlns:a="http://schemas.openxmlformats.org/drawingml/2006/main">
               <a:ext uri="{FF2B5EF4-FFF2-40B4-BE49-F238E27FC236}">
-                <a16:creationId xmlns:a16="http://schemas.microsoft.com/office/drawing/2014/main" id="{8C0076E8-36F5-44DB-A113-1B42768E2D65}"/>
+                <a16:creationId xmlns:a16="http://schemas.microsoft.com/office/drawing/2014/main" id="{82B9CC80-69EA-44C1-B741-8485F4410D89}"/>
               </a:ext>
             </a:extLst>
           </p:cNvPr>
@@ -14333,7 +14333,7 @@
           <p:cNvPr id="3" name="">
             <a:extLst xmlns:a="http://schemas.openxmlformats.org/drawingml/2006/main">
               <a:ext uri="{FF2B5EF4-FFF2-40B4-BE49-F238E27FC236}">
-                <a16:creationId xmlns:a16="http://schemas.microsoft.com/office/drawing/2014/main" id="{604EC443-8B77-4CC1-B119-F9C524C926DE}"/>
+                <a16:creationId xmlns:a16="http://schemas.microsoft.com/office/drawing/2014/main" id="{FA360772-4957-437A-9B1D-62BA7EB0A2AB}"/>
               </a:ext>
             </a:extLst>
           </p:cNvPr>
@@ -14363,7 +14363,7 @@
           <p:cNvPr id="4" name="">
             <a:extLst xmlns:a="http://schemas.openxmlformats.org/drawingml/2006/main">
               <a:ext uri="{FF2B5EF4-FFF2-40B4-BE49-F238E27FC236}">
-                <a16:creationId xmlns:a16="http://schemas.microsoft.com/office/drawing/2014/main" id="{2371797F-F714-4DDB-B743-CB633E255979}"/>
+                <a16:creationId xmlns:a16="http://schemas.microsoft.com/office/drawing/2014/main" id="{6F4ACD14-07E0-43F3-A561-784528C9B595}"/>
               </a:ext>
             </a:extLst>
           </p:cNvPr>
@@ -14431,7 +14431,7 @@
           <p:cNvPr id="5" name="">
             <a:extLst xmlns:a="http://schemas.openxmlformats.org/drawingml/2006/main">
               <a:ext uri="{FF2B5EF4-FFF2-40B4-BE49-F238E27FC236}">
-                <a16:creationId xmlns:a16="http://schemas.microsoft.com/office/drawing/2014/main" id="{E5586034-8530-42CA-A928-BA29B818F192}"/>
+                <a16:creationId xmlns:a16="http://schemas.microsoft.com/office/drawing/2014/main" id="{C0740F74-47BA-44D6-AC6B-782B63C366DD}"/>
               </a:ext>
             </a:extLst>
           </p:cNvPr>
@@ -14499,7 +14499,7 @@
           <p:cNvPr id="6" name="Chart">
             <a:extLst xmlns:a="http://schemas.openxmlformats.org/drawingml/2006/main">
               <a:ext uri="{FF2B5EF4-FFF2-40B4-BE49-F238E27FC236}">
-                <a16:creationId xmlns:a16="http://schemas.microsoft.com/office/drawing/2014/main" id="{6D759FD8-D693-4B53-90BD-62FAB996F520}"/>
+                <a16:creationId xmlns:a16="http://schemas.microsoft.com/office/drawing/2014/main" id="{4866993B-CB6D-41E8-90F8-4E2BD6832CBD}"/>
               </a:ext>
             </a:extLst>
           </p:cNvPr>
@@ -14512,7 +14512,7 @@
         </p:xfrm>
         <a:graphic xmlns:a="http://schemas.openxmlformats.org/drawingml/2006/main">
           <a:graphicData uri="http://schemas.openxmlformats.org/drawingml/2006/chart">
-            <c:chart xmlns:r="http://schemas.openxmlformats.org/officeDocument/2006/relationships" xmlns:c="http://schemas.openxmlformats.org/drawingml/2006/chart" r:id="Rb53e1c7dd2c7413b"/>
+            <c:chart xmlns:r="http://schemas.openxmlformats.org/officeDocument/2006/relationships" xmlns:c="http://schemas.openxmlformats.org/drawingml/2006/chart" r:id="R2486b2d6f5a94aca"/>
           </a:graphicData>
         </a:graphic>
       </p:graphicFrame>
@@ -14521,7 +14521,7 @@
           <p:cNvPr id="7" name="">
             <a:extLst xmlns:a="http://schemas.openxmlformats.org/drawingml/2006/main">
               <a:ext uri="{FF2B5EF4-FFF2-40B4-BE49-F238E27FC236}">
-                <a16:creationId xmlns:a16="http://schemas.microsoft.com/office/drawing/2014/main" id="{C1C8B77B-420F-4D4C-A2E7-CC1EA686FB87}"/>
+                <a16:creationId xmlns:a16="http://schemas.microsoft.com/office/drawing/2014/main" id="{78C18474-30CB-4566-8D63-FC5774D96CFA}"/>
               </a:ext>
             </a:extLst>
           </p:cNvPr>
@@ -14589,7 +14589,7 @@
           <p:cNvPr id="8" name="">
             <a:extLst xmlns:a="http://schemas.openxmlformats.org/drawingml/2006/main">
               <a:ext uri="{FF2B5EF4-FFF2-40B4-BE49-F238E27FC236}">
-                <a16:creationId xmlns:a16="http://schemas.microsoft.com/office/drawing/2014/main" id="{826A33C9-FEEE-4F4B-A2BF-85AE52C2E271}"/>
+                <a16:creationId xmlns:a16="http://schemas.microsoft.com/office/drawing/2014/main" id="{C444AD33-E11C-4D20-97A6-0C3D6B7F8F67}"/>
               </a:ext>
             </a:extLst>
           </p:cNvPr>
@@ -14680,7 +14680,7 @@
           <p:cNvPr id="9" name="">
             <a:extLst xmlns:a="http://schemas.openxmlformats.org/drawingml/2006/main">
               <a:ext uri="{FF2B5EF4-FFF2-40B4-BE49-F238E27FC236}">
-                <a16:creationId xmlns:a16="http://schemas.microsoft.com/office/drawing/2014/main" id="{80AB195D-49E2-4009-AF2B-C2D2590D86A2}"/>
+                <a16:creationId xmlns:a16="http://schemas.microsoft.com/office/drawing/2014/main" id="{938D695C-FF86-4604-9AB6-491DE62AB1B2}"/>
               </a:ext>
             </a:extLst>
           </p:cNvPr>
@@ -14748,7 +14748,7 @@
           <p:cNvPr id="10" name="">
             <a:extLst xmlns:a="http://schemas.openxmlformats.org/drawingml/2006/main">
               <a:ext uri="{FF2B5EF4-FFF2-40B4-BE49-F238E27FC236}">
-                <a16:creationId xmlns:a16="http://schemas.microsoft.com/office/drawing/2014/main" id="{4E64E390-3432-43D2-A592-D17D23D10DB5}"/>
+                <a16:creationId xmlns:a16="http://schemas.microsoft.com/office/drawing/2014/main" id="{E9314410-F30E-4240-80A0-85E89379DFD2}"/>
               </a:ext>
             </a:extLst>
           </p:cNvPr>
@@ -14816,7 +14816,7 @@
           <p:cNvPr id="11" name="">
             <a:extLst xmlns:a="http://schemas.openxmlformats.org/drawingml/2006/main">
               <a:ext uri="{FF2B5EF4-FFF2-40B4-BE49-F238E27FC236}">
-                <a16:creationId xmlns:a16="http://schemas.microsoft.com/office/drawing/2014/main" id="{DD66B0C1-789D-4C03-A544-E22E1CCA16DB}"/>
+                <a16:creationId xmlns:a16="http://schemas.microsoft.com/office/drawing/2014/main" id="{96946BEA-C64A-4708-8E69-FAE910BE2FF5}"/>
               </a:ext>
             </a:extLst>
           </p:cNvPr>
@@ -14884,7 +14884,7 @@
           <p:cNvPr id="12" name="">
             <a:extLst xmlns:a="http://schemas.openxmlformats.org/drawingml/2006/main">
               <a:ext uri="{FF2B5EF4-FFF2-40B4-BE49-F238E27FC236}">
-                <a16:creationId xmlns:a16="http://schemas.microsoft.com/office/drawing/2014/main" id="{4EF97218-02F6-430B-B093-AAC9939291CA}"/>
+                <a16:creationId xmlns:a16="http://schemas.microsoft.com/office/drawing/2014/main" id="{4DA2097D-D954-479C-8467-90FCDE9AAECC}"/>
               </a:ext>
             </a:extLst>
           </p:cNvPr>
@@ -14947,10 +14947,78 @@
           </a:p>
         </p:txBody>
       </p:sp>
+      <p:sp>
+        <p:nvSpPr>
+          <p:cNvPr id="13" name="">
+            <a:extLst xmlns:a="http://schemas.openxmlformats.org/drawingml/2006/main">
+              <a:ext uri="{FF2B5EF4-FFF2-40B4-BE49-F238E27FC236}">
+                <a16:creationId xmlns:a16="http://schemas.microsoft.com/office/drawing/2014/main" id="{7B060C53-02C0-4F2F-8CAB-BB22A839FB43}"/>
+              </a:ext>
+            </a:extLst>
+          </p:cNvPr>
+          <p:cNvSpPr>
+            <a:spLocks xmlns:a="http://schemas.openxmlformats.org/drawingml/2006/main" noGrp="1"/>
+          </p:cNvSpPr>
+          <p:nvPr/>
+        </p:nvSpPr>
+        <p:spPr>
+          <a:xfrm xmlns:a="http://schemas.openxmlformats.org/drawingml/2006/main">
+            <a:off x="666750" y="5810250"/>
+            <a:ext cx="10287000" cy="285750"/>
+          </a:xfrm>
+          <a:prstGeom xmlns:a="http://schemas.openxmlformats.org/drawingml/2006/main" prst="rect">
+            <a:avLst/>
+          </a:prstGeom>
+          <a:noFill xmlns:a="http://schemas.openxmlformats.org/drawingml/2006/main"/>
+          <a:ln xmlns:a="http://schemas.openxmlformats.org/drawingml/2006/main" w="0">
+            <a:noFill/>
+          </a:ln>
+        </p:spPr>
+        <p:txBody>
+          <a:bodyPr xmlns:a="http://schemas.openxmlformats.org/drawingml/2006/main" anchor="ctr">
+            <a:noAutofit/>
+          </a:bodyPr>
+          <a:lstStyle xmlns:a="http://schemas.openxmlformats.org/drawingml/2006/main">
+            <a:defPPr algn="ctr">
+              <a:defRPr sz="1050" b="0">
+                <a:solidFill>
+                  <a:srgbClr val="627D98"/>
+                </a:solidFill>
+                <a:latin typeface="Helvetica Neue"/>
+                <a:ea typeface="Helvetica Neue"/>
+                <a:cs typeface="Helvetica Neue"/>
+              </a:defRPr>
+            </a:defPPr>
+          </a:lstStyle>
+          <a:p xmlns:a="http://schemas.openxmlformats.org/drawingml/2006/main">
+            <a:pPr algn="ctr">
+              <a:defRPr sz="1050" b="0">
+                <a:solidFill>
+                  <a:srgbClr val="627D98"/>
+                </a:solidFill>
+                <a:latin typeface="Helvetica Neue"/>
+                <a:ea typeface="Helvetica Neue"/>
+                <a:cs typeface="Helvetica Neue"/>
+              </a:defRPr>
+            </a:pPr>
+            <a:r>
+              <a:rPr sz="1050" b="0">
+                <a:solidFill>
+                  <a:srgbClr val="627D98"/>
+                </a:solidFill>
+                <a:latin typeface="Helvetica Neue"/>
+                <a:ea typeface="Helvetica Neue"/>
+                <a:cs typeface="Helvetica Neue"/>
+              </a:rPr>
+              <a:t>Saved reference run shown. Fresh Colab: AUROC 0.556 vs 0.444; same -0.111 change.</a:t>
+            </a:r>
+          </a:p>
+        </p:txBody>
+      </p:sp>
     </p:spTree>
     <p:extLst>
       <p:ext uri="{BB962C8B-B14F-4D97-AF65-F5344CB8AC3E}">
-        <p14:creationId xmlns:p14="http://schemas.microsoft.com/office/powerpoint/2010/main" val="1721008052"/>
+        <p14:creationId xmlns:p14="http://schemas.microsoft.com/office/powerpoint/2010/main" val="2146830317"/>
       </p:ext>
     </p:extLst>
   </p:cSld>
@@ -14981,7 +15049,7 @@
           <p:cNvPr id="26" name="">
             <a:extLst xmlns:a="http://schemas.openxmlformats.org/drawingml/2006/main">
               <a:ext uri="{FF2B5EF4-FFF2-40B4-BE49-F238E27FC236}">
-                <a16:creationId xmlns:a16="http://schemas.microsoft.com/office/drawing/2014/main" id="{30F3A33D-1508-4C3F-A139-AA9DDA37D771}"/>
+                <a16:creationId xmlns:a16="http://schemas.microsoft.com/office/drawing/2014/main" id="{E54799D3-1B28-49D9-8813-F337D34F224A}"/>
               </a:ext>
             </a:extLst>
           </p:cNvPr>
@@ -15049,7 +15117,7 @@
           <p:cNvPr id="2" name="">
             <a:extLst xmlns:a="http://schemas.openxmlformats.org/drawingml/2006/main">
               <a:ext uri="{FF2B5EF4-FFF2-40B4-BE49-F238E27FC236}">
-                <a16:creationId xmlns:a16="http://schemas.microsoft.com/office/drawing/2014/main" id="{4F223D47-6111-49B3-9FE7-C4DF57751D0E}"/>
+                <a16:creationId xmlns:a16="http://schemas.microsoft.com/office/drawing/2014/main" id="{8604EE6A-54CA-45CB-9F51-9236E70D90BF}"/>
               </a:ext>
             </a:extLst>
           </p:cNvPr>
@@ -15117,7 +15185,7 @@
           <p:cNvPr id="3" name="">
             <a:extLst xmlns:a="http://schemas.openxmlformats.org/drawingml/2006/main">
               <a:ext uri="{FF2B5EF4-FFF2-40B4-BE49-F238E27FC236}">
-                <a16:creationId xmlns:a16="http://schemas.microsoft.com/office/drawing/2014/main" id="{831500E4-634E-40B9-AB58-EF5EB414EEF3}"/>
+                <a16:creationId xmlns:a16="http://schemas.microsoft.com/office/drawing/2014/main" id="{09B1E017-B6E6-4F4B-B210-3EA4F1569ECE}"/>
               </a:ext>
             </a:extLst>
           </p:cNvPr>
@@ -15147,7 +15215,7 @@
           <p:cNvPr id="4" name="">
             <a:extLst xmlns:a="http://schemas.openxmlformats.org/drawingml/2006/main">
               <a:ext uri="{FF2B5EF4-FFF2-40B4-BE49-F238E27FC236}">
-                <a16:creationId xmlns:a16="http://schemas.microsoft.com/office/drawing/2014/main" id="{5185A349-A7C5-4E05-8596-A73E7EF5B1F8}"/>
+                <a16:creationId xmlns:a16="http://schemas.microsoft.com/office/drawing/2014/main" id="{CB7EE025-0FB3-4CA3-9E9B-DB2CDBABE90D}"/>
               </a:ext>
             </a:extLst>
           </p:cNvPr>
@@ -15215,7 +15283,7 @@
           <p:cNvPr id="5" name="">
             <a:extLst xmlns:a="http://schemas.openxmlformats.org/drawingml/2006/main">
               <a:ext uri="{FF2B5EF4-FFF2-40B4-BE49-F238E27FC236}">
-                <a16:creationId xmlns:a16="http://schemas.microsoft.com/office/drawing/2014/main" id="{C2D4D682-2D0F-497C-B1CB-2C968E037EF6}"/>
+                <a16:creationId xmlns:a16="http://schemas.microsoft.com/office/drawing/2014/main" id="{A12D4D34-428B-4730-AF30-BC87CA1A070D}"/>
               </a:ext>
             </a:extLst>
           </p:cNvPr>
@@ -15283,7 +15351,7 @@
           <p:cNvPr id="6" name="">
             <a:extLst xmlns:a="http://schemas.openxmlformats.org/drawingml/2006/main">
               <a:ext uri="{FF2B5EF4-FFF2-40B4-BE49-F238E27FC236}">
-                <a16:creationId xmlns:a16="http://schemas.microsoft.com/office/drawing/2014/main" id="{65205DB3-E61A-417E-A283-299D09AC4AB0}"/>
+                <a16:creationId xmlns:a16="http://schemas.microsoft.com/office/drawing/2014/main" id="{909CDD7B-BF77-4232-97EC-B80904C863D4}"/>
               </a:ext>
             </a:extLst>
           </p:cNvPr>
@@ -15351,7 +15419,7 @@
           <p:cNvPr id="7" name="">
             <a:extLst xmlns:a="http://schemas.openxmlformats.org/drawingml/2006/main">
               <a:ext uri="{FF2B5EF4-FFF2-40B4-BE49-F238E27FC236}">
-                <a16:creationId xmlns:a16="http://schemas.microsoft.com/office/drawing/2014/main" id="{B3EC7C77-2255-4D15-BE12-2D50CB005AE5}"/>
+                <a16:creationId xmlns:a16="http://schemas.microsoft.com/office/drawing/2014/main" id="{41F80ADF-9F46-4DF7-936C-DD9ECD89A32F}"/>
               </a:ext>
             </a:extLst>
           </p:cNvPr>
@@ -15381,7 +15449,7 @@
           <p:cNvPr id="8" name="">
             <a:extLst xmlns:a="http://schemas.openxmlformats.org/drawingml/2006/main">
               <a:ext uri="{FF2B5EF4-FFF2-40B4-BE49-F238E27FC236}">
-                <a16:creationId xmlns:a16="http://schemas.microsoft.com/office/drawing/2014/main" id="{AB38D2D3-DB25-4E8D-9EC9-AF4031A7F9E2}"/>
+                <a16:creationId xmlns:a16="http://schemas.microsoft.com/office/drawing/2014/main" id="{0540C7ED-D3D2-4F84-AE9B-887F80EB27BA}"/>
               </a:ext>
             </a:extLst>
           </p:cNvPr>
@@ -15449,7 +15517,7 @@
           <p:cNvPr id="9" name="">
             <a:extLst xmlns:a="http://schemas.openxmlformats.org/drawingml/2006/main">
               <a:ext uri="{FF2B5EF4-FFF2-40B4-BE49-F238E27FC236}">
-                <a16:creationId xmlns:a16="http://schemas.microsoft.com/office/drawing/2014/main" id="{1246D232-6C5F-451E-A5FC-8EE8C8407DA6}"/>
+                <a16:creationId xmlns:a16="http://schemas.microsoft.com/office/drawing/2014/main" id="{53576E1A-2DA8-4EE0-B584-D4CD9E643AF7}"/>
               </a:ext>
             </a:extLst>
           </p:cNvPr>
@@ -15517,7 +15585,7 @@
           <p:cNvPr id="10" name="">
             <a:extLst xmlns:a="http://schemas.openxmlformats.org/drawingml/2006/main">
               <a:ext uri="{FF2B5EF4-FFF2-40B4-BE49-F238E27FC236}">
-                <a16:creationId xmlns:a16="http://schemas.microsoft.com/office/drawing/2014/main" id="{60522291-D003-41ED-BDAF-88F08F2AB48C}"/>
+                <a16:creationId xmlns:a16="http://schemas.microsoft.com/office/drawing/2014/main" id="{B88A4F88-3D96-4F76-BA03-F3D59950DC69}"/>
               </a:ext>
             </a:extLst>
           </p:cNvPr>
@@ -15585,7 +15653,7 @@
           <p:cNvPr id="11" name="">
             <a:extLst xmlns:a="http://schemas.openxmlformats.org/drawingml/2006/main">
               <a:ext uri="{FF2B5EF4-FFF2-40B4-BE49-F238E27FC236}">
-                <a16:creationId xmlns:a16="http://schemas.microsoft.com/office/drawing/2014/main" id="{74F6DFF5-8D5F-4F80-AB84-816A8D4E5C82}"/>
+                <a16:creationId xmlns:a16="http://schemas.microsoft.com/office/drawing/2014/main" id="{5B250AA7-E9B2-4600-8B35-C7CA92C40C7E}"/>
               </a:ext>
             </a:extLst>
           </p:cNvPr>
@@ -15653,7 +15721,7 @@
           <p:cNvPr id="12" name="">
             <a:extLst xmlns:a="http://schemas.openxmlformats.org/drawingml/2006/main">
               <a:ext uri="{FF2B5EF4-FFF2-40B4-BE49-F238E27FC236}">
-                <a16:creationId xmlns:a16="http://schemas.microsoft.com/office/drawing/2014/main" id="{1A245C65-B25F-4C0E-B119-DAE84EB51114}"/>
+                <a16:creationId xmlns:a16="http://schemas.microsoft.com/office/drawing/2014/main" id="{5EF74709-DBD2-4BE7-AC49-5F329F6017B5}"/>
               </a:ext>
             </a:extLst>
           </p:cNvPr>
@@ -15721,7 +15789,7 @@
           <p:cNvPr id="13" name="">
             <a:extLst xmlns:a="http://schemas.openxmlformats.org/drawingml/2006/main">
               <a:ext uri="{FF2B5EF4-FFF2-40B4-BE49-F238E27FC236}">
-                <a16:creationId xmlns:a16="http://schemas.microsoft.com/office/drawing/2014/main" id="{5F69C99B-043C-4FA4-BB36-D794715A08C6}"/>
+                <a16:creationId xmlns:a16="http://schemas.microsoft.com/office/drawing/2014/main" id="{C3F6AC4B-7EC3-4CEC-A9FC-036537DD32A1}"/>
               </a:ext>
             </a:extLst>
           </p:cNvPr>
@@ -15751,7 +15819,7 @@
           <p:cNvPr id="14" name="">
             <a:extLst xmlns:a="http://schemas.openxmlformats.org/drawingml/2006/main">
               <a:ext uri="{FF2B5EF4-FFF2-40B4-BE49-F238E27FC236}">
-                <a16:creationId xmlns:a16="http://schemas.microsoft.com/office/drawing/2014/main" id="{B9A06AAF-3E1F-450F-BFA8-DE7A0AB07747}"/>
+                <a16:creationId xmlns:a16="http://schemas.microsoft.com/office/drawing/2014/main" id="{7004CE83-D402-4F57-B608-EF11BF650A14}"/>
               </a:ext>
             </a:extLst>
           </p:cNvPr>
@@ -15819,7 +15887,7 @@
           <p:cNvPr id="15" name="">
             <a:extLst xmlns:a="http://schemas.openxmlformats.org/drawingml/2006/main">
               <a:ext uri="{FF2B5EF4-FFF2-40B4-BE49-F238E27FC236}">
-                <a16:creationId xmlns:a16="http://schemas.microsoft.com/office/drawing/2014/main" id="{DC3C7ACB-963C-471C-9387-F74673FB1936}"/>
+                <a16:creationId xmlns:a16="http://schemas.microsoft.com/office/drawing/2014/main" id="{C8AA3D64-8958-45C8-91C2-3602EDB6A546}"/>
               </a:ext>
             </a:extLst>
           </p:cNvPr>
@@ -15887,7 +15955,7 @@
           <p:cNvPr id="16" name="">
             <a:extLst xmlns:a="http://schemas.openxmlformats.org/drawingml/2006/main">
               <a:ext uri="{FF2B5EF4-FFF2-40B4-BE49-F238E27FC236}">
-                <a16:creationId xmlns:a16="http://schemas.microsoft.com/office/drawing/2014/main" id="{6F92A901-EF74-4B8D-9E06-17EF3BB94A1E}"/>
+                <a16:creationId xmlns:a16="http://schemas.microsoft.com/office/drawing/2014/main" id="{8873FB95-7FC2-457A-BE5D-C960BE83EB72}"/>
               </a:ext>
             </a:extLst>
           </p:cNvPr>
@@ -15955,7 +16023,7 @@
           <p:cNvPr id="17" name="">
             <a:extLst xmlns:a="http://schemas.openxmlformats.org/drawingml/2006/main">
               <a:ext uri="{FF2B5EF4-FFF2-40B4-BE49-F238E27FC236}">
-                <a16:creationId xmlns:a16="http://schemas.microsoft.com/office/drawing/2014/main" id="{63E204F4-7331-4482-AA6C-FDE2705F0136}"/>
+                <a16:creationId xmlns:a16="http://schemas.microsoft.com/office/drawing/2014/main" id="{FF4851D7-AC98-4251-8C54-8615F57BB9A4}"/>
               </a:ext>
             </a:extLst>
           </p:cNvPr>
@@ -16023,7 +16091,7 @@
           <p:cNvPr id="18" name="">
             <a:extLst xmlns:a="http://schemas.openxmlformats.org/drawingml/2006/main">
               <a:ext uri="{FF2B5EF4-FFF2-40B4-BE49-F238E27FC236}">
-                <a16:creationId xmlns:a16="http://schemas.microsoft.com/office/drawing/2014/main" id="{28D366B2-3929-4A2F-A52D-3B987D26E4F3}"/>
+                <a16:creationId xmlns:a16="http://schemas.microsoft.com/office/drawing/2014/main" id="{51829173-5DF1-4B44-94DE-7A3BF145D2B2}"/>
               </a:ext>
             </a:extLst>
           </p:cNvPr>
@@ -16091,7 +16159,7 @@
           <p:cNvPr id="19" name="">
             <a:extLst xmlns:a="http://schemas.openxmlformats.org/drawingml/2006/main">
               <a:ext uri="{FF2B5EF4-FFF2-40B4-BE49-F238E27FC236}">
-                <a16:creationId xmlns:a16="http://schemas.microsoft.com/office/drawing/2014/main" id="{D3A1024C-F735-488A-A30F-CBA67E82AB92}"/>
+                <a16:creationId xmlns:a16="http://schemas.microsoft.com/office/drawing/2014/main" id="{CA985948-BCE0-47CE-97A6-03F2FAEC20BA}"/>
               </a:ext>
             </a:extLst>
           </p:cNvPr>
@@ -16121,7 +16189,7 @@
           <p:cNvPr id="20" name="">
             <a:extLst xmlns:a="http://schemas.openxmlformats.org/drawingml/2006/main">
               <a:ext uri="{FF2B5EF4-FFF2-40B4-BE49-F238E27FC236}">
-                <a16:creationId xmlns:a16="http://schemas.microsoft.com/office/drawing/2014/main" id="{6C7BD841-5B32-46F2-A7A0-D6D3959F5A79}"/>
+                <a16:creationId xmlns:a16="http://schemas.microsoft.com/office/drawing/2014/main" id="{E3F8972E-D30B-468A-B348-6C486D208179}"/>
               </a:ext>
             </a:extLst>
           </p:cNvPr>
@@ -16189,7 +16257,7 @@
           <p:cNvPr id="21" name="">
             <a:extLst xmlns:a="http://schemas.openxmlformats.org/drawingml/2006/main">
               <a:ext uri="{FF2B5EF4-FFF2-40B4-BE49-F238E27FC236}">
-                <a16:creationId xmlns:a16="http://schemas.microsoft.com/office/drawing/2014/main" id="{1DCDFF77-1739-4A5E-AA23-75AF28821EF0}"/>
+                <a16:creationId xmlns:a16="http://schemas.microsoft.com/office/drawing/2014/main" id="{87779ABA-6953-4E7B-8EE2-EDD48D46E493}"/>
               </a:ext>
             </a:extLst>
           </p:cNvPr>
@@ -16257,7 +16325,7 @@
           <p:cNvPr id="22" name="">
             <a:extLst xmlns:a="http://schemas.openxmlformats.org/drawingml/2006/main">
               <a:ext uri="{FF2B5EF4-FFF2-40B4-BE49-F238E27FC236}">
-                <a16:creationId xmlns:a16="http://schemas.microsoft.com/office/drawing/2014/main" id="{7E8F29AF-1D23-441D-912D-617DBD1139C9}"/>
+                <a16:creationId xmlns:a16="http://schemas.microsoft.com/office/drawing/2014/main" id="{886EE3E5-B5EB-4B6C-872F-25293F79E641}"/>
               </a:ext>
             </a:extLst>
           </p:cNvPr>
@@ -16325,7 +16393,7 @@
           <p:cNvPr id="23" name="">
             <a:extLst xmlns:a="http://schemas.openxmlformats.org/drawingml/2006/main">
               <a:ext uri="{FF2B5EF4-FFF2-40B4-BE49-F238E27FC236}">
-                <a16:creationId xmlns:a16="http://schemas.microsoft.com/office/drawing/2014/main" id="{EBCBEC5C-9FD0-4858-A71F-CAECD1D2E5B0}"/>
+                <a16:creationId xmlns:a16="http://schemas.microsoft.com/office/drawing/2014/main" id="{51797BF1-17D2-4BE6-A595-B818A157C71F}"/>
               </a:ext>
             </a:extLst>
           </p:cNvPr>
@@ -16393,7 +16461,7 @@
           <p:cNvPr id="24" name="">
             <a:extLst xmlns:a="http://schemas.openxmlformats.org/drawingml/2006/main">
               <a:ext uri="{FF2B5EF4-FFF2-40B4-BE49-F238E27FC236}">
-                <a16:creationId xmlns:a16="http://schemas.microsoft.com/office/drawing/2014/main" id="{6A1FB774-7E2F-418B-BF77-0EDAD7BBD0E3}"/>
+                <a16:creationId xmlns:a16="http://schemas.microsoft.com/office/drawing/2014/main" id="{67A000D7-28B8-4DB7-BE7E-6B69539FD0F7}"/>
               </a:ext>
             </a:extLst>
           </p:cNvPr>
@@ -16423,7 +16491,7 @@
           <p:cNvPr id="25" name="">
             <a:extLst xmlns:a="http://schemas.openxmlformats.org/drawingml/2006/main">
               <a:ext uri="{FF2B5EF4-FFF2-40B4-BE49-F238E27FC236}">
-                <a16:creationId xmlns:a16="http://schemas.microsoft.com/office/drawing/2014/main" id="{0ED2C354-849B-4968-B2A7-7CA9DD815AB0}"/>
+                <a16:creationId xmlns:a16="http://schemas.microsoft.com/office/drawing/2014/main" id="{A6E850EB-B41A-4A6F-BDE5-F1A80A4777BC}"/>
               </a:ext>
             </a:extLst>
           </p:cNvPr>
@@ -16489,7 +16557,7 @@
     </p:spTree>
     <p:extLst>
       <p:ext uri="{BB962C8B-B14F-4D97-AF65-F5344CB8AC3E}">
-        <p14:creationId xmlns:p14="http://schemas.microsoft.com/office/powerpoint/2010/main" val="1989837514"/>
+        <p14:creationId xmlns:p14="http://schemas.microsoft.com/office/powerpoint/2010/main" val="882436518"/>
       </p:ext>
     </p:extLst>
   </p:cSld>
@@ -16520,7 +16588,7 @@
           <p:cNvPr id="25" name="">
             <a:extLst xmlns:a="http://schemas.openxmlformats.org/drawingml/2006/main">
               <a:ext uri="{FF2B5EF4-FFF2-40B4-BE49-F238E27FC236}">
-                <a16:creationId xmlns:a16="http://schemas.microsoft.com/office/drawing/2014/main" id="{0B1325B5-0685-4604-9173-55675B1C3F68}"/>
+                <a16:creationId xmlns:a16="http://schemas.microsoft.com/office/drawing/2014/main" id="{CE9B59C9-967A-4290-9947-022E472A8F3D}"/>
               </a:ext>
             </a:extLst>
           </p:cNvPr>
@@ -16588,7 +16656,7 @@
           <p:cNvPr id="2" name="">
             <a:extLst xmlns:a="http://schemas.openxmlformats.org/drawingml/2006/main">
               <a:ext uri="{FF2B5EF4-FFF2-40B4-BE49-F238E27FC236}">
-                <a16:creationId xmlns:a16="http://schemas.microsoft.com/office/drawing/2014/main" id="{FDAF2F5A-3B04-4105-B6A4-2B826F7680F0}"/>
+                <a16:creationId xmlns:a16="http://schemas.microsoft.com/office/drawing/2014/main" id="{31E7E9F0-7074-4395-948E-8A0357AA3381}"/>
               </a:ext>
             </a:extLst>
           </p:cNvPr>
@@ -16656,7 +16724,7 @@
           <p:cNvPr id="3" name="">
             <a:extLst xmlns:a="http://schemas.openxmlformats.org/drawingml/2006/main">
               <a:ext uri="{FF2B5EF4-FFF2-40B4-BE49-F238E27FC236}">
-                <a16:creationId xmlns:a16="http://schemas.microsoft.com/office/drawing/2014/main" id="{099791F7-1731-43C2-8371-CFB2C3B73690}"/>
+                <a16:creationId xmlns:a16="http://schemas.microsoft.com/office/drawing/2014/main" id="{E9506E36-4561-43C5-B91E-32A1457E6124}"/>
               </a:ext>
             </a:extLst>
           </p:cNvPr>
@@ -16686,7 +16754,7 @@
           <p:cNvPr id="4" name="">
             <a:extLst xmlns:a="http://schemas.openxmlformats.org/drawingml/2006/main">
               <a:ext uri="{FF2B5EF4-FFF2-40B4-BE49-F238E27FC236}">
-                <a16:creationId xmlns:a16="http://schemas.microsoft.com/office/drawing/2014/main" id="{F7D7378B-69C0-4E35-8147-B66750AFFA2C}"/>
+                <a16:creationId xmlns:a16="http://schemas.microsoft.com/office/drawing/2014/main" id="{CA416BD1-7C48-4C9A-921D-479A1B359688}"/>
               </a:ext>
             </a:extLst>
           </p:cNvPr>
@@ -16754,7 +16822,7 @@
           <p:cNvPr id="5" name="">
             <a:extLst xmlns:a="http://schemas.openxmlformats.org/drawingml/2006/main">
               <a:ext uri="{FF2B5EF4-FFF2-40B4-BE49-F238E27FC236}">
-                <a16:creationId xmlns:a16="http://schemas.microsoft.com/office/drawing/2014/main" id="{A379DD6C-10C2-45B4-933D-2100460947EB}"/>
+                <a16:creationId xmlns:a16="http://schemas.microsoft.com/office/drawing/2014/main" id="{4015C0A1-73D6-4BCB-AF8F-4B598050FDBA}"/>
               </a:ext>
             </a:extLst>
           </p:cNvPr>
@@ -16822,7 +16890,7 @@
           <p:cNvPr id="6" name="">
             <a:extLst xmlns:a="http://schemas.openxmlformats.org/drawingml/2006/main">
               <a:ext uri="{FF2B5EF4-FFF2-40B4-BE49-F238E27FC236}">
-                <a16:creationId xmlns:a16="http://schemas.microsoft.com/office/drawing/2014/main" id="{383C3E4D-3357-41AE-9192-1B70B90BF1B8}"/>
+                <a16:creationId xmlns:a16="http://schemas.microsoft.com/office/drawing/2014/main" id="{8D1300C9-39E8-4B38-BB3E-C12ADC7E373D}"/>
               </a:ext>
             </a:extLst>
           </p:cNvPr>
@@ -16856,7 +16924,7 @@
           <p:cNvPr id="7" name="">
             <a:extLst xmlns:a="http://schemas.openxmlformats.org/drawingml/2006/main">
               <a:ext uri="{FF2B5EF4-FFF2-40B4-BE49-F238E27FC236}">
-                <a16:creationId xmlns:a16="http://schemas.microsoft.com/office/drawing/2014/main" id="{AC77B3B7-ADE9-453C-9588-B7BC39CE81CA}"/>
+                <a16:creationId xmlns:a16="http://schemas.microsoft.com/office/drawing/2014/main" id="{070E7F36-B4D7-4362-ACDB-40715106D34D}"/>
               </a:ext>
             </a:extLst>
           </p:cNvPr>
@@ -16924,7 +16992,7 @@
           <p:cNvPr id="8" name="">
             <a:extLst xmlns:a="http://schemas.openxmlformats.org/drawingml/2006/main">
               <a:ext uri="{FF2B5EF4-FFF2-40B4-BE49-F238E27FC236}">
-                <a16:creationId xmlns:a16="http://schemas.microsoft.com/office/drawing/2014/main" id="{125AC37D-8694-451B-B453-1223424D8F0D}"/>
+                <a16:creationId xmlns:a16="http://schemas.microsoft.com/office/drawing/2014/main" id="{D6CF38D1-D1C7-4268-AA32-BA0633C69C2C}"/>
               </a:ext>
             </a:extLst>
           </p:cNvPr>
@@ -16992,7 +17060,7 @@
           <p:cNvPr id="9" name="">
             <a:extLst xmlns:a="http://schemas.openxmlformats.org/drawingml/2006/main">
               <a:ext uri="{FF2B5EF4-FFF2-40B4-BE49-F238E27FC236}">
-                <a16:creationId xmlns:a16="http://schemas.microsoft.com/office/drawing/2014/main" id="{1F6D45E9-9B19-45DF-95E6-C4D3B32CEFE0}"/>
+                <a16:creationId xmlns:a16="http://schemas.microsoft.com/office/drawing/2014/main" id="{1EAAEA71-6A6B-473D-8B8F-93FDD422CF54}"/>
               </a:ext>
             </a:extLst>
           </p:cNvPr>
@@ -17026,7 +17094,7 @@
           <p:cNvPr id="10" name="">
             <a:extLst xmlns:a="http://schemas.openxmlformats.org/drawingml/2006/main">
               <a:ext uri="{FF2B5EF4-FFF2-40B4-BE49-F238E27FC236}">
-                <a16:creationId xmlns:a16="http://schemas.microsoft.com/office/drawing/2014/main" id="{B174C6B8-DB58-4FA6-A357-EE9964225322}"/>
+                <a16:creationId xmlns:a16="http://schemas.microsoft.com/office/drawing/2014/main" id="{27109A18-20F8-4EDD-B0B9-566FB92A291C}"/>
               </a:ext>
             </a:extLst>
           </p:cNvPr>
@@ -17094,7 +17162,7 @@
           <p:cNvPr id="11" name="">
             <a:extLst xmlns:a="http://schemas.openxmlformats.org/drawingml/2006/main">
               <a:ext uri="{FF2B5EF4-FFF2-40B4-BE49-F238E27FC236}">
-                <a16:creationId xmlns:a16="http://schemas.microsoft.com/office/drawing/2014/main" id="{A48E00C6-ADC9-490E-8DAB-34624511EFD0}"/>
+                <a16:creationId xmlns:a16="http://schemas.microsoft.com/office/drawing/2014/main" id="{C658D28F-D6C0-4871-A020-2F1B4DCC655E}"/>
               </a:ext>
             </a:extLst>
           </p:cNvPr>
@@ -17162,7 +17230,7 @@
           <p:cNvPr id="12" name="">
             <a:extLst xmlns:a="http://schemas.openxmlformats.org/drawingml/2006/main">
               <a:ext uri="{FF2B5EF4-FFF2-40B4-BE49-F238E27FC236}">
-                <a16:creationId xmlns:a16="http://schemas.microsoft.com/office/drawing/2014/main" id="{C0524FDE-E5F0-4A3D-8F6A-1AA55AFF7810}"/>
+                <a16:creationId xmlns:a16="http://schemas.microsoft.com/office/drawing/2014/main" id="{B00644EC-8979-4A12-9AC6-AD2C5D9B9A46}"/>
               </a:ext>
             </a:extLst>
           </p:cNvPr>
@@ -17196,7 +17264,7 @@
           <p:cNvPr id="13" name="">
             <a:extLst xmlns:a="http://schemas.openxmlformats.org/drawingml/2006/main">
               <a:ext uri="{FF2B5EF4-FFF2-40B4-BE49-F238E27FC236}">
-                <a16:creationId xmlns:a16="http://schemas.microsoft.com/office/drawing/2014/main" id="{15A354EF-4C31-499B-BC65-0F97AB56A6F2}"/>
+                <a16:creationId xmlns:a16="http://schemas.microsoft.com/office/drawing/2014/main" id="{96161803-CE75-4B41-8EE4-F8501D224D1D}"/>
               </a:ext>
             </a:extLst>
           </p:cNvPr>
@@ -17264,7 +17332,7 @@
           <p:cNvPr id="14" name="">
             <a:extLst xmlns:a="http://schemas.openxmlformats.org/drawingml/2006/main">
               <a:ext uri="{FF2B5EF4-FFF2-40B4-BE49-F238E27FC236}">
-                <a16:creationId xmlns:a16="http://schemas.microsoft.com/office/drawing/2014/main" id="{412C1EEF-5B54-40ED-975E-0DF213887D34}"/>
+                <a16:creationId xmlns:a16="http://schemas.microsoft.com/office/drawing/2014/main" id="{49030C6D-3B36-42AA-AEF5-F9B4152005ED}"/>
               </a:ext>
             </a:extLst>
           </p:cNvPr>
@@ -17332,7 +17400,7 @@
           <p:cNvPr id="15" name="">
             <a:extLst xmlns:a="http://schemas.openxmlformats.org/drawingml/2006/main">
               <a:ext uri="{FF2B5EF4-FFF2-40B4-BE49-F238E27FC236}">
-                <a16:creationId xmlns:a16="http://schemas.microsoft.com/office/drawing/2014/main" id="{D6A393EC-7105-41C1-9C84-AD9DDE0B0B39}"/>
+                <a16:creationId xmlns:a16="http://schemas.microsoft.com/office/drawing/2014/main" id="{48B53CA2-72A8-46D6-BB62-45FC8449BF87}"/>
               </a:ext>
             </a:extLst>
           </p:cNvPr>
@@ -17366,7 +17434,7 @@
           <p:cNvPr id="16" name="">
             <a:extLst xmlns:a="http://schemas.openxmlformats.org/drawingml/2006/main">
               <a:ext uri="{FF2B5EF4-FFF2-40B4-BE49-F238E27FC236}">
-                <a16:creationId xmlns:a16="http://schemas.microsoft.com/office/drawing/2014/main" id="{10C63C87-119A-465E-B617-BA11E8E20BA9}"/>
+                <a16:creationId xmlns:a16="http://schemas.microsoft.com/office/drawing/2014/main" id="{5FEA86A6-FF87-4061-BD81-093477E1A7C9}"/>
               </a:ext>
             </a:extLst>
           </p:cNvPr>
@@ -17434,7 +17502,7 @@
           <p:cNvPr id="17" name="">
             <a:extLst xmlns:a="http://schemas.openxmlformats.org/drawingml/2006/main">
               <a:ext uri="{FF2B5EF4-FFF2-40B4-BE49-F238E27FC236}">
-                <a16:creationId xmlns:a16="http://schemas.microsoft.com/office/drawing/2014/main" id="{1D6C4C53-6CF6-4B93-BC9C-7909CE83F3F8}"/>
+                <a16:creationId xmlns:a16="http://schemas.microsoft.com/office/drawing/2014/main" id="{07363EB3-F139-4661-9C8A-B1BD0F6EB9BB}"/>
               </a:ext>
             </a:extLst>
           </p:cNvPr>
@@ -17548,7 +17616,7 @@
           <p:cNvPr id="18" name="">
             <a:extLst xmlns:a="http://schemas.openxmlformats.org/drawingml/2006/main">
               <a:ext uri="{FF2B5EF4-FFF2-40B4-BE49-F238E27FC236}">
-                <a16:creationId xmlns:a16="http://schemas.microsoft.com/office/drawing/2014/main" id="{22CC8572-2AFC-4983-BA99-F278DC29B083}"/>
+                <a16:creationId xmlns:a16="http://schemas.microsoft.com/office/drawing/2014/main" id="{FB67C729-5FE7-41EF-B78D-A39F7F37B630}"/>
               </a:ext>
             </a:extLst>
           </p:cNvPr>
@@ -17578,7 +17646,7 @@
           <p:cNvPr id="19" name="">
             <a:extLst xmlns:a="http://schemas.openxmlformats.org/drawingml/2006/main">
               <a:ext uri="{FF2B5EF4-FFF2-40B4-BE49-F238E27FC236}">
-                <a16:creationId xmlns:a16="http://schemas.microsoft.com/office/drawing/2014/main" id="{07F25FFD-65E6-4384-9BC7-715E62891D06}"/>
+                <a16:creationId xmlns:a16="http://schemas.microsoft.com/office/drawing/2014/main" id="{2126CD3E-E6C1-4492-8770-91378FCF428D}"/>
               </a:ext>
             </a:extLst>
           </p:cNvPr>
@@ -17608,7 +17676,7 @@
           <p:cNvPr id="20" name="">
             <a:extLst xmlns:a="http://schemas.openxmlformats.org/drawingml/2006/main">
               <a:ext uri="{FF2B5EF4-FFF2-40B4-BE49-F238E27FC236}">
-                <a16:creationId xmlns:a16="http://schemas.microsoft.com/office/drawing/2014/main" id="{B51BDADB-4B0A-4EA1-813D-4B36629D79D9}"/>
+                <a16:creationId xmlns:a16="http://schemas.microsoft.com/office/drawing/2014/main" id="{C66DC799-3723-4927-BDBC-56929D6FEBA0}"/>
               </a:ext>
             </a:extLst>
           </p:cNvPr>
@@ -17638,7 +17706,7 @@
           <p:cNvPr id="21" name="">
             <a:extLst xmlns:a="http://schemas.openxmlformats.org/drawingml/2006/main">
               <a:ext uri="{FF2B5EF4-FFF2-40B4-BE49-F238E27FC236}">
-                <a16:creationId xmlns:a16="http://schemas.microsoft.com/office/drawing/2014/main" id="{DC68448D-1A45-4DBA-86A0-0182AB6E32D5}"/>
+                <a16:creationId xmlns:a16="http://schemas.microsoft.com/office/drawing/2014/main" id="{898327BF-8595-4F70-964E-2463E5D0177C}"/>
               </a:ext>
             </a:extLst>
           </p:cNvPr>
@@ -17668,7 +17736,7 @@
           <p:cNvPr id="22" name="">
             <a:extLst xmlns:a="http://schemas.openxmlformats.org/drawingml/2006/main">
               <a:ext uri="{FF2B5EF4-FFF2-40B4-BE49-F238E27FC236}">
-                <a16:creationId xmlns:a16="http://schemas.microsoft.com/office/drawing/2014/main" id="{7A5A93FF-799C-4CF6-ACF4-4194B29B5C6C}"/>
+                <a16:creationId xmlns:a16="http://schemas.microsoft.com/office/drawing/2014/main" id="{D0C017B8-D51D-4C67-B671-C0B460C90E4C}"/>
               </a:ext>
             </a:extLst>
           </p:cNvPr>
@@ -17736,7 +17804,7 @@
           <p:cNvPr id="23" name="">
             <a:extLst xmlns:a="http://schemas.openxmlformats.org/drawingml/2006/main">
               <a:ext uri="{FF2B5EF4-FFF2-40B4-BE49-F238E27FC236}">
-                <a16:creationId xmlns:a16="http://schemas.microsoft.com/office/drawing/2014/main" id="{F6C21CA2-E9BF-4EF0-A82E-ECEA190E559C}"/>
+                <a16:creationId xmlns:a16="http://schemas.microsoft.com/office/drawing/2014/main" id="{76E59753-F6D7-489D-B14F-3A272474F7FD}"/>
               </a:ext>
             </a:extLst>
           </p:cNvPr>
@@ -17804,7 +17872,7 @@
           <p:cNvPr id="24" name="">
             <a:extLst xmlns:a="http://schemas.openxmlformats.org/drawingml/2006/main">
               <a:ext uri="{FF2B5EF4-FFF2-40B4-BE49-F238E27FC236}">
-                <a16:creationId xmlns:a16="http://schemas.microsoft.com/office/drawing/2014/main" id="{DBDF5F42-BFDB-4F78-84D0-C4C1F37965A3}"/>
+                <a16:creationId xmlns:a16="http://schemas.microsoft.com/office/drawing/2014/main" id="{D6E37139-8086-4E17-AF95-6B804E7A54E2}"/>
               </a:ext>
             </a:extLst>
           </p:cNvPr>
@@ -17870,7 +17938,7 @@
     </p:spTree>
     <p:extLst>
       <p:ext uri="{BB962C8B-B14F-4D97-AF65-F5344CB8AC3E}">
-        <p14:creationId xmlns:p14="http://schemas.microsoft.com/office/powerpoint/2010/main" val="1263854518"/>
+        <p14:creationId xmlns:p14="http://schemas.microsoft.com/office/powerpoint/2010/main" val="116858779"/>
       </p:ext>
     </p:extLst>
   </p:cSld>
@@ -17901,7 +17969,7 @@
           <p:cNvPr id="18" name="">
             <a:extLst xmlns:a="http://schemas.openxmlformats.org/drawingml/2006/main">
               <a:ext uri="{FF2B5EF4-FFF2-40B4-BE49-F238E27FC236}">
-                <a16:creationId xmlns:a16="http://schemas.microsoft.com/office/drawing/2014/main" id="{3144ED24-8BBC-4FDA-9B97-EC8205395459}"/>
+                <a16:creationId xmlns:a16="http://schemas.microsoft.com/office/drawing/2014/main" id="{C240AD35-E1C5-4AB4-AF46-4B7929DFF66C}"/>
               </a:ext>
             </a:extLst>
           </p:cNvPr>
@@ -17969,7 +18037,7 @@
           <p:cNvPr id="2" name="">
             <a:extLst xmlns:a="http://schemas.openxmlformats.org/drawingml/2006/main">
               <a:ext uri="{FF2B5EF4-FFF2-40B4-BE49-F238E27FC236}">
-                <a16:creationId xmlns:a16="http://schemas.microsoft.com/office/drawing/2014/main" id="{29993895-023B-44FE-9350-CFBE2CBE321E}"/>
+                <a16:creationId xmlns:a16="http://schemas.microsoft.com/office/drawing/2014/main" id="{4D631714-FE58-49EB-9469-73E3672EF4DA}"/>
               </a:ext>
             </a:extLst>
           </p:cNvPr>
@@ -18037,7 +18105,7 @@
           <p:cNvPr id="3" name="">
             <a:extLst xmlns:a="http://schemas.openxmlformats.org/drawingml/2006/main">
               <a:ext uri="{FF2B5EF4-FFF2-40B4-BE49-F238E27FC236}">
-                <a16:creationId xmlns:a16="http://schemas.microsoft.com/office/drawing/2014/main" id="{CEB4559D-D470-4019-8A9E-494DC425C83D}"/>
+                <a16:creationId xmlns:a16="http://schemas.microsoft.com/office/drawing/2014/main" id="{63E09E6F-4253-4641-AE71-E9CB49412236}"/>
               </a:ext>
             </a:extLst>
           </p:cNvPr>
@@ -18067,7 +18135,7 @@
           <p:cNvPr id="4" name="">
             <a:extLst xmlns:a="http://schemas.openxmlformats.org/drawingml/2006/main">
               <a:ext uri="{FF2B5EF4-FFF2-40B4-BE49-F238E27FC236}">
-                <a16:creationId xmlns:a16="http://schemas.microsoft.com/office/drawing/2014/main" id="{7A8DB1A4-BD0E-4441-BC42-6CF7ABB88439}"/>
+                <a16:creationId xmlns:a16="http://schemas.microsoft.com/office/drawing/2014/main" id="{0C8377A0-E873-40A8-A5DA-28F5876821FA}"/>
               </a:ext>
             </a:extLst>
           </p:cNvPr>
@@ -18135,7 +18203,7 @@
           <p:cNvPr id="5" name="">
             <a:extLst xmlns:a="http://schemas.openxmlformats.org/drawingml/2006/main">
               <a:ext uri="{FF2B5EF4-FFF2-40B4-BE49-F238E27FC236}">
-                <a16:creationId xmlns:a16="http://schemas.microsoft.com/office/drawing/2014/main" id="{3217D930-98DF-4BDF-9DDF-86A1F871822A}"/>
+                <a16:creationId xmlns:a16="http://schemas.microsoft.com/office/drawing/2014/main" id="{67400308-685D-40FC-8DEF-9FDDC6CFC16C}"/>
               </a:ext>
             </a:extLst>
           </p:cNvPr>
@@ -18203,7 +18271,7 @@
           <p:cNvPr id="6" name="Chart">
             <a:extLst xmlns:a="http://schemas.openxmlformats.org/drawingml/2006/main">
               <a:ext uri="{FF2B5EF4-FFF2-40B4-BE49-F238E27FC236}">
-                <a16:creationId xmlns:a16="http://schemas.microsoft.com/office/drawing/2014/main" id="{1F1050F9-6B88-448E-B198-56D5F70FEA91}"/>
+                <a16:creationId xmlns:a16="http://schemas.microsoft.com/office/drawing/2014/main" id="{AF297FD3-E26F-49FA-89E5-EA941FE71521}"/>
               </a:ext>
             </a:extLst>
           </p:cNvPr>
@@ -18216,7 +18284,7 @@
         </p:xfrm>
         <a:graphic xmlns:a="http://schemas.openxmlformats.org/drawingml/2006/main">
           <a:graphicData uri="http://schemas.openxmlformats.org/drawingml/2006/chart">
-            <c:chart xmlns:r="http://schemas.openxmlformats.org/officeDocument/2006/relationships" xmlns:c="http://schemas.openxmlformats.org/drawingml/2006/chart" r:id="R3daf59009b094d90"/>
+            <c:chart xmlns:r="http://schemas.openxmlformats.org/officeDocument/2006/relationships" xmlns:c="http://schemas.openxmlformats.org/drawingml/2006/chart" r:id="Ra0080620088841aa"/>
           </a:graphicData>
         </a:graphic>
       </p:graphicFrame>
@@ -18225,7 +18293,7 @@
           <p:cNvPr id="7" name="Chart">
             <a:extLst xmlns:a="http://schemas.openxmlformats.org/drawingml/2006/main">
               <a:ext uri="{FF2B5EF4-FFF2-40B4-BE49-F238E27FC236}">
-                <a16:creationId xmlns:a16="http://schemas.microsoft.com/office/drawing/2014/main" id="{EADBFD34-6C3A-45CA-A7CD-E1BA7B9B2ED8}"/>
+                <a16:creationId xmlns:a16="http://schemas.microsoft.com/office/drawing/2014/main" id="{444F9983-B286-4E90-9A0C-8602DB5ADE53}"/>
               </a:ext>
             </a:extLst>
           </p:cNvPr>
@@ -18238,7 +18306,7 @@
         </p:xfrm>
         <a:graphic xmlns:a="http://schemas.openxmlformats.org/drawingml/2006/main">
           <a:graphicData uri="http://schemas.openxmlformats.org/drawingml/2006/chart">
-            <c:chart xmlns:r="http://schemas.openxmlformats.org/officeDocument/2006/relationships" xmlns:c="http://schemas.openxmlformats.org/drawingml/2006/chart" r:id="R4232d1dcbb2d452e"/>
+            <c:chart xmlns:r="http://schemas.openxmlformats.org/officeDocument/2006/relationships" xmlns:c="http://schemas.openxmlformats.org/drawingml/2006/chart" r:id="Rdc9df921de234a53"/>
           </a:graphicData>
         </a:graphic>
       </p:graphicFrame>
@@ -18247,7 +18315,7 @@
           <p:cNvPr id="8" name="">
             <a:extLst xmlns:a="http://schemas.openxmlformats.org/drawingml/2006/main">
               <a:ext uri="{FF2B5EF4-FFF2-40B4-BE49-F238E27FC236}">
-                <a16:creationId xmlns:a16="http://schemas.microsoft.com/office/drawing/2014/main" id="{FF2B3455-A0D1-428E-A8F0-D617A0450F94}"/>
+                <a16:creationId xmlns:a16="http://schemas.microsoft.com/office/drawing/2014/main" id="{41B2D453-07C2-4598-8EE1-09FD8EE832D4}"/>
               </a:ext>
             </a:extLst>
           </p:cNvPr>
@@ -18315,7 +18383,7 @@
           <p:cNvPr id="9" name="">
             <a:extLst xmlns:a="http://schemas.openxmlformats.org/drawingml/2006/main">
               <a:ext uri="{FF2B5EF4-FFF2-40B4-BE49-F238E27FC236}">
-                <a16:creationId xmlns:a16="http://schemas.microsoft.com/office/drawing/2014/main" id="{55F76535-FB12-4983-99BD-B649504D6FF4}"/>
+                <a16:creationId xmlns:a16="http://schemas.microsoft.com/office/drawing/2014/main" id="{0BD99CC7-A2DB-4815-BB28-4D9BA3ED454B}"/>
               </a:ext>
             </a:extLst>
           </p:cNvPr>
@@ -18383,7 +18451,7 @@
           <p:cNvPr id="10" name="">
             <a:extLst xmlns:a="http://schemas.openxmlformats.org/drawingml/2006/main">
               <a:ext uri="{FF2B5EF4-FFF2-40B4-BE49-F238E27FC236}">
-                <a16:creationId xmlns:a16="http://schemas.microsoft.com/office/drawing/2014/main" id="{EF163810-D4C7-4DF0-B86C-4A2F24EF5B9C}"/>
+                <a16:creationId xmlns:a16="http://schemas.microsoft.com/office/drawing/2014/main" id="{6A32CAF0-196E-419F-A3DD-A3EF0036446D}"/>
               </a:ext>
             </a:extLst>
           </p:cNvPr>
@@ -18451,7 +18519,7 @@
           <p:cNvPr id="11" name="">
             <a:extLst xmlns:a="http://schemas.openxmlformats.org/drawingml/2006/main">
               <a:ext uri="{FF2B5EF4-FFF2-40B4-BE49-F238E27FC236}">
-                <a16:creationId xmlns:a16="http://schemas.microsoft.com/office/drawing/2014/main" id="{65DCBDC6-B178-4574-A26E-AB03AAE46EFC}"/>
+                <a16:creationId xmlns:a16="http://schemas.microsoft.com/office/drawing/2014/main" id="{1184A46A-65BB-498D-AF47-EB9A6886580C}"/>
               </a:ext>
             </a:extLst>
           </p:cNvPr>
@@ -18519,7 +18587,7 @@
           <p:cNvPr id="12" name="">
             <a:extLst xmlns:a="http://schemas.openxmlformats.org/drawingml/2006/main">
               <a:ext uri="{FF2B5EF4-FFF2-40B4-BE49-F238E27FC236}">
-                <a16:creationId xmlns:a16="http://schemas.microsoft.com/office/drawing/2014/main" id="{C6497A18-DAFD-4DDE-8E15-1B30501FEA12}"/>
+                <a16:creationId xmlns:a16="http://schemas.microsoft.com/office/drawing/2014/main" id="{B221622F-6E26-4F95-8425-230F015098A2}"/>
               </a:ext>
             </a:extLst>
           </p:cNvPr>
@@ -18587,7 +18655,7 @@
           <p:cNvPr id="13" name="">
             <a:extLst xmlns:a="http://schemas.openxmlformats.org/drawingml/2006/main">
               <a:ext uri="{FF2B5EF4-FFF2-40B4-BE49-F238E27FC236}">
-                <a16:creationId xmlns:a16="http://schemas.microsoft.com/office/drawing/2014/main" id="{DED56BA7-6532-4918-B079-019157E64414}"/>
+                <a16:creationId xmlns:a16="http://schemas.microsoft.com/office/drawing/2014/main" id="{E0A99A03-0C51-4716-AAB6-379B5C091FEF}"/>
               </a:ext>
             </a:extLst>
           </p:cNvPr>
@@ -18655,7 +18723,7 @@
           <p:cNvPr id="14" name="">
             <a:extLst xmlns:a="http://schemas.openxmlformats.org/drawingml/2006/main">
               <a:ext uri="{FF2B5EF4-FFF2-40B4-BE49-F238E27FC236}">
-                <a16:creationId xmlns:a16="http://schemas.microsoft.com/office/drawing/2014/main" id="{979C2A86-B685-4667-82F5-3EF924AAD5D0}"/>
+                <a16:creationId xmlns:a16="http://schemas.microsoft.com/office/drawing/2014/main" id="{AC6ACA4E-BD89-4C58-BC2B-6A19E48D3381}"/>
               </a:ext>
             </a:extLst>
           </p:cNvPr>
@@ -18723,7 +18791,7 @@
           <p:cNvPr id="15" name="">
             <a:extLst xmlns:a="http://schemas.openxmlformats.org/drawingml/2006/main">
               <a:ext uri="{FF2B5EF4-FFF2-40B4-BE49-F238E27FC236}">
-                <a16:creationId xmlns:a16="http://schemas.microsoft.com/office/drawing/2014/main" id="{4D33C5FC-0A58-4080-A827-38FC33135054}"/>
+                <a16:creationId xmlns:a16="http://schemas.microsoft.com/office/drawing/2014/main" id="{4E4FB188-A16F-46B3-A513-D06F27D25637}"/>
               </a:ext>
             </a:extLst>
           </p:cNvPr>
@@ -18791,7 +18859,7 @@
           <p:cNvPr id="16" name="">
             <a:extLst xmlns:a="http://schemas.openxmlformats.org/drawingml/2006/main">
               <a:ext uri="{FF2B5EF4-FFF2-40B4-BE49-F238E27FC236}">
-                <a16:creationId xmlns:a16="http://schemas.microsoft.com/office/drawing/2014/main" id="{FC529233-02D2-4042-820D-0A673A7F045E}"/>
+                <a16:creationId xmlns:a16="http://schemas.microsoft.com/office/drawing/2014/main" id="{D938F139-FDFC-4074-A8C8-6573F64A885E}"/>
               </a:ext>
             </a:extLst>
           </p:cNvPr>
@@ -18859,7 +18927,7 @@
           <p:cNvPr id="17" name="">
             <a:extLst xmlns:a="http://schemas.openxmlformats.org/drawingml/2006/main">
               <a:ext uri="{FF2B5EF4-FFF2-40B4-BE49-F238E27FC236}">
-                <a16:creationId xmlns:a16="http://schemas.microsoft.com/office/drawing/2014/main" id="{983AC69A-4FFD-4B5C-A39E-2C6A0DB38519}"/>
+                <a16:creationId xmlns:a16="http://schemas.microsoft.com/office/drawing/2014/main" id="{8FFBA5E5-98DE-4A90-BE0D-267860DA897D}"/>
               </a:ext>
             </a:extLst>
           </p:cNvPr>
@@ -18925,7 +18993,7 @@
     </p:spTree>
     <p:extLst>
       <p:ext uri="{BB962C8B-B14F-4D97-AF65-F5344CB8AC3E}">
-        <p14:creationId xmlns:p14="http://schemas.microsoft.com/office/powerpoint/2010/main" val="1299230944"/>
+        <p14:creationId xmlns:p14="http://schemas.microsoft.com/office/powerpoint/2010/main" val="1475405770"/>
       </p:ext>
     </p:extLst>
   </p:cSld>

</xml_diff>